<commit_message>
update for Eastern Cape
</commit_message>
<xml_diff>
--- a/Amidel_eTender_Scraper_Presentation.pptx
+++ b/Amidel_eTender_Scraper_Presentation.pptx
@@ -3278,7 +3278,7 @@
         <p:spPr>
           <a:xfrm>
             <a:off x="640080" y="1554480"/>
-            <a:ext cx="2560320" cy="365760"/>
+            <a:ext cx="2926080" cy="365760"/>
           </a:xfrm>
           <a:prstGeom prst="rect">
             <a:avLst/>
@@ -3321,7 +3321,7 @@
         <p:spPr>
           <a:xfrm>
             <a:off x="658368" y="1572768"/>
-            <a:ext cx="2560320" cy="347472"/>
+            <a:ext cx="2926080" cy="347472"/>
           </a:xfrm>
           <a:prstGeom prst="rect">
             <a:avLst/>
@@ -3342,7 +3342,7 @@
                 </a:solidFill>
                 <a:latin typeface="Segoe UI"/>
               </a:rPr>
-              <a:t>INTERNAL TOOL  ·  v2.0</a:t>
+              <a:t>PROCUREMENT INTELLIGENCE  ·  SOUTH AFRICA</a:t>
             </a:r>
           </a:p>
         </p:txBody>
@@ -3413,7 +3413,7 @@
                 </a:solidFill>
                 <a:latin typeface="Segoe UI"/>
               </a:rPr>
-              <a:t>Automate. Aggregate. Act.</a:t>
+              <a:t>Never miss a government tender again.</a:t>
             </a:r>
           </a:p>
         </p:txBody>
@@ -3448,7 +3448,7 @@
                 </a:solidFill>
                 <a:latin typeface="Segoe UI"/>
               </a:rPr>
-              <a:t>A branded desktop application that scrapes South African government tender listings from etenders.gov.za, organises them into structured Excel outputs, and keeps the team's equation tracker up to date — all with a single click.</a:t>
+              <a:t>Automated daily monitoring of etenders.gov.za — structured reports, department-level breakdowns, and actionable tender intelligence delivered to your team without lifting a finger.</a:t>
             </a:r>
           </a:p>
         </p:txBody>
@@ -3554,7 +3554,7 @@
                 </a:solidFill>
                 <a:latin typeface="Segoe UI"/>
               </a:rPr>
-              <a:t>Confidential  ·  Internal Use Only  ·  2026</a:t>
+              <a:t>Confidential  ·  2026</a:t>
             </a:r>
           </a:p>
         </p:txBody>
@@ -3779,7 +3779,7 @@
                 </a:solidFill>
                 <a:latin typeface="Segoe UI"/>
               </a:rPr>
-              <a:t>Summary</a:t>
+              <a:t>Let's Get Started</a:t>
             </a:r>
           </a:p>
         </p:txBody>
@@ -3814,7 +3814,7 @@
                 </a:solidFill>
                 <a:latin typeface="Segoe UI"/>
               </a:rPr>
-              <a:t>What the Amidel eTender Scraper delivers</a:t>
+              <a:t>What the Amidel eTender Scraper delivers for your organisation</a:t>
             </a:r>
           </a:p>
         </p:txBody>
@@ -3849,7 +3849,7 @@
                 </a:solidFill>
                 <a:latin typeface="Segoe UI"/>
               </a:rPr>
-              <a:t>✓  Saves hours of manual tender checking every batch week</a:t>
+              <a:t>✓  Automated monitoring of 26 government departments — twice a week</a:t>
             </a:r>
           </a:p>
         </p:txBody>
@@ -3884,7 +3884,7 @@
                 </a:solidFill>
                 <a:latin typeface="Segoe UI"/>
               </a:rPr>
-              <a:t>✓  Produces consistently formatted, audit-ready Excel files</a:t>
+              <a:t>✓  Clean, structured Excel reports ready to act on immediately</a:t>
             </a:r>
           </a:p>
         </p:txBody>
@@ -3919,7 +3919,7 @@
                 </a:solidFill>
                 <a:latin typeface="Segoe UI"/>
               </a:rPr>
-              <a:t>✓  Tracks NNT / ICT / RFQ counts across 6 rolling batches</a:t>
+              <a:t>✓  Department-level tender counts with ICT and RFQ breakdowns</a:t>
             </a:r>
           </a:p>
         </p:txBody>
@@ -3954,7 +3954,7 @@
                 </a:solidFill>
                 <a:latin typeface="Segoe UI"/>
               </a:rPr>
-              <a:t>✓  Monitors 25 departments and organs of state automatically</a:t>
+              <a:t>✓  Briefing session dates and compulsory attendance flagged upfront</a:t>
             </a:r>
           </a:p>
         </p:txBody>
@@ -3989,7 +3989,7 @@
                 </a:solidFill>
                 <a:latin typeface="Segoe UI"/>
               </a:rPr>
-              <a:t>✓  One-click operation — no technical knowledge required</a:t>
+              <a:t>✓  Rolling 6-period trend tracker — always up to date</a:t>
             </a:r>
           </a:p>
         </p:txBody>
@@ -4024,7 +4024,7 @@
                 </a:solidFill>
                 <a:latin typeface="Segoe UI"/>
               </a:rPr>
-              <a:t>✓  Runs on any Windows machine with Chrome installed</a:t>
+              <a:t>✓  Customisable to your department watchlist and reporting needs</a:t>
             </a:r>
           </a:p>
         </p:txBody>
@@ -4037,7 +4037,7 @@
         </p:nvSpPr>
         <p:spPr>
           <a:xfrm>
-            <a:off x="9262872" y="1371600"/>
+            <a:off x="9262872" y="1280160"/>
             <a:ext cx="2743200" cy="1005840"/>
           </a:xfrm>
           <a:prstGeom prst="rect">
@@ -4059,8 +4059,8 @@
                 </a:solidFill>
                 <a:latin typeface="Segoe UI"/>
               </a:rPr>
-              <a:t>Get
-Started</a:t>
+              <a:t>Contact
+Amidel</a:t>
             </a:r>
           </a:p>
         </p:txBody>
@@ -4073,8 +4073,8 @@
         </p:nvSpPr>
         <p:spPr>
           <a:xfrm>
-            <a:off x="9308592" y="2468880"/>
-            <a:ext cx="2651760" cy="2743200"/>
+            <a:off x="9308592" y="2423160"/>
+            <a:ext cx="2651760" cy="2926080"/>
           </a:xfrm>
           <a:prstGeom prst="rect">
             <a:avLst/>
@@ -4087,67 +4087,99 @@
           </a:bodyPr>
           <a:lstStyle/>
           <a:p>
-            <a:pPr algn="l">
+            <a:pPr algn="ctr">
               <a:spcBef>
-                <a:spcPts val="600"/>
+                <a:spcPts val="400"/>
               </a:spcBef>
             </a:pPr>
             <a:r>
-              <a:rPr sz="1100" b="1">
+              <a:rPr sz="1200" b="1" i="0">
                 <a:solidFill>
                   <a:srgbClr val="F5A000"/>
                 </a:solidFill>
-                <a:latin typeface="Consolas"/>
-              </a:rPr>
-              <a:t>1.  pip install -r requirements.txt</a:t>
-            </a:r>
-          </a:p>
-          <a:p>
-            <a:pPr algn="l">
+                <a:latin typeface="Segoe UI"/>
+              </a:rPr>
+              <a:t>amidel.co.za</a:t>
+            </a:r>
+          </a:p>
+          <a:p>
+            <a:pPr algn="ctr">
               <a:spcBef>
-                <a:spcPts val="600"/>
+                <a:spcPts val="400"/>
               </a:spcBef>
             </a:pPr>
             <a:r>
-              <a:rPr sz="1100" b="0">
-                <a:solidFill>
-                  <a:srgbClr val="E0E4EE"/>
-                </a:solidFill>
-                <a:latin typeface="Consolas"/>
-              </a:rPr>
-              <a:t>2.  python main.py</a:t>
-            </a:r>
-          </a:p>
-          <a:p>
-            <a:pPr algn="l">
+              <a:rPr sz="1200" b="0" i="0">
+                <a:solidFill>
+                  <a:srgbClr val="FFFFFF"/>
+                </a:solidFill>
+                <a:latin typeface="Segoe UI"/>
+              </a:rPr>
+              <a:t> </a:t>
+            </a:r>
+          </a:p>
+          <a:p>
+            <a:pPr algn="ctr">
               <a:spcBef>
-                <a:spcPts val="600"/>
+                <a:spcPts val="400"/>
               </a:spcBef>
             </a:pPr>
             <a:r>
-              <a:rPr sz="1100" b="0">
-                <a:solidFill>
-                  <a:srgbClr val="E0E4EE"/>
-                </a:solidFill>
-                <a:latin typeface="Segoe UI"/>
-              </a:rPr>
-              <a:t>3.  Pick batch type &amp; week</a:t>
-            </a:r>
-          </a:p>
-          <a:p>
-            <a:pPr algn="l">
+              <a:rPr sz="1100" b="0" i="0">
+                <a:solidFill>
+                  <a:srgbClr val="FFFFFF"/>
+                </a:solidFill>
+                <a:latin typeface="Segoe UI"/>
+              </a:rPr>
+              <a:t>Request a demo</a:t>
+            </a:r>
+          </a:p>
+          <a:p>
+            <a:pPr algn="ctr">
               <a:spcBef>
-                <a:spcPts val="600"/>
+                <a:spcPts val="400"/>
               </a:spcBef>
             </a:pPr>
             <a:r>
-              <a:rPr sz="1100" b="0">
+              <a:rPr sz="1100" b="0" i="0">
+                <a:solidFill>
+                  <a:srgbClr val="FFFFFF"/>
+                </a:solidFill>
+                <a:latin typeface="Segoe UI"/>
+              </a:rPr>
+              <a:t>or tailored setup</a:t>
+            </a:r>
+          </a:p>
+          <a:p>
+            <a:pPr algn="ctr">
+              <a:spcBef>
+                <a:spcPts val="400"/>
+              </a:spcBef>
+            </a:pPr>
+            <a:r>
+              <a:rPr sz="1200" b="0" i="0">
+                <a:solidFill>
+                  <a:srgbClr val="FFFFFF"/>
+                </a:solidFill>
+                <a:latin typeface="Segoe UI"/>
+              </a:rPr>
+              <a:t> </a:t>
+            </a:r>
+          </a:p>
+          <a:p>
+            <a:pPr algn="ctr">
+              <a:spcBef>
+                <a:spcPts val="400"/>
+              </a:spcBef>
+            </a:pPr>
+            <a:r>
+              <a:rPr sz="1200" b="0" i="1">
                 <a:solidFill>
                   <a:srgbClr val="E0E4EE"/>
                 </a:solidFill>
                 <a:latin typeface="Segoe UI"/>
               </a:rPr>
-              <a:t>4.  Click Run Scraper</a:t>
+              <a:t>Beyond Technology</a:t>
             </a:r>
           </a:p>
         </p:txBody>
@@ -4321,7 +4353,7 @@
                 </a:solidFill>
                 <a:latin typeface="Segoe UI"/>
               </a:rPr>
-              <a:t>The Problem</a:t>
+              <a:t>The Challenge</a:t>
             </a:r>
           </a:p>
         </p:txBody>
@@ -4356,7 +4388,7 @@
                 </a:solidFill>
                 <a:latin typeface="Segoe UI"/>
               </a:rPr>
-              <a:t>Why manual tender tracking doesn't scale</a:t>
+              <a:t>Monitoring government tenders manually is unsustainable</a:t>
             </a:r>
           </a:p>
         </p:txBody>
@@ -4434,7 +4466,7 @@
                 </a:solidFill>
                 <a:latin typeface="Segoe UI"/>
               </a:rPr>
-              <a:t>Amidel (Pty) Ltd  |  Beyond Technology  |  eTender Scraper</a:t>
+              <a:t>Amidel (Pty) Ltd  |  Beyond Technology  |  Tender Intelligence</a:t>
             </a:r>
           </a:p>
         </p:txBody>
@@ -4604,7 +4636,7 @@
                 </a:solidFill>
                 <a:latin typeface="Segoe UI"/>
               </a:rPr>
-              <a:t>• etenders.gov.za must be visited daily</a:t>
+              <a:t>• The eTenders portal must be checked every business day</a:t>
             </a:r>
           </a:p>
           <a:p>
@@ -4616,7 +4648,7 @@
                 </a:solidFill>
                 <a:latin typeface="Segoe UI"/>
               </a:rPr>
-              <a:t>• Tenders span multiple pages — clicking through each one</a:t>
+              <a:t>• Tenders span multiple pages — no bulk export available</a:t>
             </a:r>
           </a:p>
           <a:p>
@@ -4628,7 +4660,7 @@
                 </a:solidFill>
                 <a:latin typeface="Segoe UI"/>
               </a:rPr>
-              <a:t>• No export or download feature on the website</a:t>
+              <a:t>• Each listing must be opened individually to see full details</a:t>
             </a:r>
           </a:p>
         </p:txBody>
@@ -4751,7 +4783,7 @@
                 </a:solidFill>
                 <a:latin typeface="Segoe UI"/>
               </a:rPr>
-              <a:t>Error-prone</a:t>
+              <a:t>Easy to miss opportunities</a:t>
             </a:r>
           </a:p>
           <a:p>
@@ -4763,7 +4795,7 @@
                 </a:solidFill>
                 <a:latin typeface="Segoe UI"/>
               </a:rPr>
-              <a:t>• Manual copy-paste introduces mistakes</a:t>
+              <a:t>• New tenders appear without notification</a:t>
             </a:r>
           </a:p>
           <a:p>
@@ -4775,7 +4807,7 @@
                 </a:solidFill>
                 <a:latin typeface="Segoe UI"/>
               </a:rPr>
-              <a:t>• Easy to miss tenders on busy days</a:t>
+              <a:t>• High-volume days mean relevant tenders get overlooked</a:t>
             </a:r>
           </a:p>
           <a:p>
@@ -4787,7 +4819,7 @@
                 </a:solidFill>
                 <a:latin typeface="Segoe UI"/>
               </a:rPr>
-              <a:t>• Duplicate entries go undetected</a:t>
+              <a:t>• Closing dates are easy to miss when checking manually</a:t>
             </a:r>
           </a:p>
         </p:txBody>
@@ -4910,7 +4942,7 @@
                 </a:solidFill>
                 <a:latin typeface="Segoe UI"/>
               </a:rPr>
-              <a:t>Hard to track trends</a:t>
+              <a:t>No structured view</a:t>
             </a:r>
           </a:p>
           <a:p>
@@ -4922,7 +4954,7 @@
                 </a:solidFill>
                 <a:latin typeface="Segoe UI"/>
               </a:rPr>
-              <a:t>• No historical view across batches</a:t>
+              <a:t>• Website data is unstructured and inconsistent</a:t>
             </a:r>
           </a:p>
           <a:p>
@@ -4934,7 +4966,7 @@
                 </a:solidFill>
                 <a:latin typeface="Segoe UI"/>
               </a:rPr>
-              <a:t>• Department-level counts require manual COUNTIF work</a:t>
+              <a:t>• ICT vs RFQ classification requires manual judgement</a:t>
             </a:r>
           </a:p>
           <a:p>
@@ -4946,7 +4978,7 @@
                 </a:solidFill>
                 <a:latin typeface="Segoe UI"/>
               </a:rPr>
-              <a:t>• Equation file maintained by hand every week</a:t>
+              <a:t>• Briefing session details are buried inside each listing</a:t>
             </a:r>
           </a:p>
         </p:txBody>
@@ -5069,7 +5101,7 @@
                 </a:solidFill>
                 <a:latin typeface="Segoe UI"/>
               </a:rPr>
-              <a:t>No structured output</a:t>
+              <a:t>No historical tracking</a:t>
             </a:r>
           </a:p>
           <a:p>
@@ -5081,7 +5113,7 @@
                 </a:solidFill>
                 <a:latin typeface="Segoe UI"/>
               </a:rPr>
-              <a:t>• Raw website data has no consistent format</a:t>
+              <a:t>• No built-in way to compare tender volumes across periods</a:t>
             </a:r>
           </a:p>
           <a:p>
@@ -5093,7 +5125,7 @@
                 </a:solidFill>
                 <a:latin typeface="Segoe UI"/>
               </a:rPr>
-              <a:t>• ICT vs RFQ classification done manually</a:t>
+              <a:t>• Department-level counts must be compiled by hand</a:t>
             </a:r>
           </a:p>
           <a:p>
@@ -5105,7 +5137,7 @@
                 </a:solidFill>
                 <a:latin typeface="Segoe UI"/>
               </a:rPr>
-              <a:t>• Briefing session details buried in expanded rows</a:t>
+              <a:t>• There is no audit trail of what was active and when</a:t>
             </a:r>
           </a:p>
         </p:txBody>
@@ -5357,7 +5389,7 @@
                 </a:solidFill>
                 <a:latin typeface="Segoe UI"/>
               </a:rPr>
-              <a:t>Amidel (Pty) Ltd  |  Beyond Technology  |  eTender Scraper</a:t>
+              <a:t>Amidel (Pty) Ltd  |  Beyond Technology  |  Tender Intelligence</a:t>
             </a:r>
           </a:p>
         </p:txBody>
@@ -5427,7 +5459,7 @@
                 </a:solidFill>
                 <a:latin typeface="Segoe UI"/>
               </a:rPr>
-              <a:t>The Amidel eTender Scraper is a branded desktop application that automates the entire tender collection and reporting workflow for the sales team — from website to Excel in one run.</a:t>
+              <a:t>The Amidel eTender Scraper automatically monitors etenders.gov.za on your behalf — collecting every relevant tender, classifying it, and delivering clean, structured reports directly to your team twice a week.</a:t>
             </a:r>
           </a:p>
         </p:txBody>
@@ -5548,7 +5580,7 @@
                 </a:solidFill>
                 <a:latin typeface="Segoe UI"/>
               </a:rPr>
-              <a:t>Automate</a:t>
+              <a:t>Monitor</a:t>
             </a:r>
           </a:p>
         </p:txBody>
@@ -5583,7 +5615,7 @@
                 </a:solidFill>
                 <a:latin typeface="Segoe UI"/>
               </a:rPr>
-              <a:t>Selenium drives Chrome to visit each tender page, expand every row, and extract all 23 data fields — no manual steps.</a:t>
+              <a:t>Automatically visits the eTenders portal for each day in the reporting period — no manual browsing required.</a:t>
             </a:r>
           </a:p>
         </p:txBody>
@@ -5618,7 +5650,7 @@
                 </a:solidFill>
                 <a:latin typeface="Segoe UI"/>
               </a:rPr>
-              <a:t>✓  Scrapes multiple days in sequence</a:t>
+              <a:t>✓  Runs across Mon–Wed and Thu–Sun periods</a:t>
             </a:r>
           </a:p>
           <a:p>
@@ -5630,7 +5662,7 @@
                 </a:solidFill>
                 <a:latin typeface="Segoe UI"/>
               </a:rPr>
-              <a:t>✓  Handles pagination automatically</a:t>
+              <a:t>✓  Covers every tender listed, every day</a:t>
             </a:r>
           </a:p>
           <a:p>
@@ -5642,7 +5674,7 @@
                 </a:solidFill>
                 <a:latin typeface="Segoe UI"/>
               </a:rPr>
-              <a:t>✓  Retry logic for network hiccups</a:t>
+              <a:t>✓  Handles large volumes without errors</a:t>
             </a:r>
           </a:p>
           <a:p>
@@ -5654,7 +5686,7 @@
                 </a:solidFill>
                 <a:latin typeface="Segoe UI"/>
               </a:rPr>
-              <a:t>✓  Duplicate detection built-in</a:t>
+              <a:t>✓  Duplicate detection built in</a:t>
             </a:r>
           </a:p>
         </p:txBody>
@@ -5775,7 +5807,7 @@
                 </a:solidFill>
                 <a:latin typeface="Segoe UI"/>
               </a:rPr>
-              <a:t>Aggregate</a:t>
+              <a:t>Classify</a:t>
             </a:r>
           </a:p>
         </p:txBody>
@@ -5810,7 +5842,7 @@
                 </a:solidFill>
                 <a:latin typeface="Segoe UI"/>
               </a:rPr>
-              <a:t>All daily files are merged into a single end-product workbook with a Tender Data tab and a Final tab containing COUNTIF formulas.</a:t>
+              <a:t>Every tender is categorised by type (RFQ, ICT, Open Tender) and matched to tracked departments automatically.</a:t>
             </a:r>
           </a:p>
         </p:txBody>
@@ -5845,7 +5877,7 @@
                 </a:solidFill>
                 <a:latin typeface="Segoe UI"/>
               </a:rPr>
-              <a:t>✓  Per-day batches saved separately</a:t>
+              <a:t>✓  26 organs of state tracked</a:t>
             </a:r>
           </a:p>
           <a:p>
@@ -5857,7 +5889,7 @@
                 </a:solidFill>
                 <a:latin typeface="Segoe UI"/>
               </a:rPr>
-              <a:t>✓  Combined RFQ &amp; ICT Checker file</a:t>
+              <a:t>✓  ICT and RFQ tenders flagged</a:t>
             </a:r>
           </a:p>
           <a:p>
@@ -5869,7 +5901,7 @@
                 </a:solidFill>
                 <a:latin typeface="Segoe UI"/>
               </a:rPr>
-              <a:t>✓  Tender Summary per department</a:t>
+              <a:t>✓  Briefing session details captured</a:t>
             </a:r>
           </a:p>
           <a:p>
@@ -5881,7 +5913,7 @@
                 </a:solidFill>
                 <a:latin typeface="Segoe UI"/>
               </a:rPr>
-              <a:t>✓  Clickable hyperlinks in Excel</a:t>
+              <a:t>✓  Department-level breakdowns produced</a:t>
             </a:r>
           </a:p>
         </p:txBody>
@@ -6002,7 +6034,7 @@
                 </a:solidFill>
                 <a:latin typeface="Segoe UI"/>
               </a:rPr>
-              <a:t>Act</a:t>
+              <a:t>Deliver</a:t>
             </a:r>
           </a:p>
         </p:txBody>
@@ -6037,7 +6069,7 @@
                 </a:solidFill>
                 <a:latin typeface="Segoe UI"/>
               </a:rPr>
-              <a:t>The equation tracker is updated automatically each run — new batch inserted, oldest dropped, borders applied, file saved.</a:t>
+              <a:t>Structured Excel reports are generated and saved immediately after each run — ready to share with your team.</a:t>
             </a:r>
           </a:p>
         </p:txBody>
@@ -6072,7 +6104,7 @@
                 </a:solidFill>
                 <a:latin typeface="Segoe UI"/>
               </a:rPr>
-              <a:t>✓  Up to 6 rolling batches tracked</a:t>
+              <a:t>✓  Per-department Tender Summary</a:t>
             </a:r>
           </a:p>
           <a:p>
@@ -6084,7 +6116,7 @@
                 </a:solidFill>
                 <a:latin typeface="Segoe UI"/>
               </a:rPr>
-              <a:t>✓  Equation file copied to batch folder</a:t>
+              <a:t>✓  Combined RFQ &amp; ICT Checker file</a:t>
             </a:r>
           </a:p>
           <a:p>
@@ -6096,7 +6128,7 @@
                 </a:solidFill>
                 <a:latin typeface="Segoe UI"/>
               </a:rPr>
-              <a:t>✓  Synced via OneDrive automatically</a:t>
+              <a:t>✓  Rolling 6-batch trend tracker</a:t>
             </a:r>
           </a:p>
           <a:p>
@@ -6108,7 +6140,7 @@
                 </a:solidFill>
                 <a:latin typeface="Segoe UI"/>
               </a:rPr>
-              <a:t>✓  Ready to present immediately</a:t>
+              <a:t>✓  Clickable links to source documents</a:t>
             </a:r>
           </a:p>
         </p:txBody>
@@ -6247,7 +6279,7 @@
                 </a:solidFill>
                 <a:latin typeface="Segoe UI"/>
               </a:rPr>
-              <a:t>Key Features</a:t>
+              <a:t>Who Benefits</a:t>
             </a:r>
           </a:p>
         </p:txBody>
@@ -6282,7 +6314,7 @@
                 </a:solidFill>
                 <a:latin typeface="Segoe UI"/>
               </a:rPr>
-              <a:t>Everything the sales team needs, nothing it doesn't</a:t>
+              <a:t>Any organisation that competes for — or tracks — government procurement</a:t>
             </a:r>
           </a:p>
         </p:txBody>
@@ -6360,7 +6392,7 @@
                 </a:solidFill>
                 <a:latin typeface="Segoe UI"/>
               </a:rPr>
-              <a:t>Amidel (Pty) Ltd  |  Beyond Technology  |  eTender Scraper</a:t>
+              <a:t>Amidel (Pty) Ltd  |  Beyond Technology  |  Tender Intelligence</a:t>
             </a:r>
           </a:p>
         </p:txBody>
@@ -6409,7 +6441,7 @@
         <p:spPr>
           <a:xfrm>
             <a:off x="411480" y="1508760"/>
-            <a:ext cx="3566160" cy="1417320"/>
+            <a:ext cx="5394960" cy="1508760"/>
           </a:xfrm>
           <a:prstGeom prst="rect">
             <a:avLst/>
@@ -6454,7 +6486,7 @@
         <p:spPr>
           <a:xfrm>
             <a:off x="411480" y="1508760"/>
-            <a:ext cx="50292" cy="1417320"/>
+            <a:ext cx="50292" cy="1508760"/>
           </a:xfrm>
           <a:prstGeom prst="rect">
             <a:avLst/>
@@ -6497,7 +6529,7 @@
         <p:spPr>
           <a:xfrm>
             <a:off x="576072" y="1636776"/>
-            <a:ext cx="3364992" cy="1289304"/>
+            <a:ext cx="5193792" cy="1380744"/>
           </a:xfrm>
           <a:prstGeom prst="rect">
             <a:avLst/>
@@ -6512,61 +6544,61 @@
           <a:p>
             <a:pPr algn="l"/>
             <a:r>
-              <a:rPr sz="1350" b="1">
+              <a:rPr sz="1400" b="1">
                 <a:solidFill>
                   <a:srgbClr val="1C3880"/>
                 </a:solidFill>
                 <a:latin typeface="Segoe UI"/>
               </a:rPr>
-              <a:t>GUI — no command line</a:t>
-            </a:r>
-          </a:p>
-          <a:p>
-            <a:pPr algn="l"/>
-            <a:r>
-              <a:rPr sz="1150" b="0" i="0">
+              <a:t>Sales &amp; Business Development</a:t>
+            </a:r>
+          </a:p>
+          <a:p>
+            <a:pPr algn="l"/>
+            <a:r>
+              <a:rPr sz="1200" b="0" i="0">
                 <a:solidFill>
                   <a:srgbClr val="333344"/>
                 </a:solidFill>
                 <a:latin typeface="Segoe UI"/>
               </a:rPr>
-              <a:t>• Amidel navy &amp; orange branded desktop window</a:t>
-            </a:r>
-          </a:p>
-          <a:p>
-            <a:pPr algn="l"/>
-            <a:r>
-              <a:rPr sz="1150" b="0" i="0">
+              <a:t>• Never miss an RFQ or open tender in your sector</a:t>
+            </a:r>
+          </a:p>
+          <a:p>
+            <a:pPr algn="l"/>
+            <a:r>
+              <a:rPr sz="1200" b="0" i="0">
                 <a:solidFill>
                   <a:srgbClr val="333344"/>
                 </a:solidFill>
                 <a:latin typeface="Segoe UI"/>
               </a:rPr>
-              <a:t>• Batch type toggle: Thursday (Mon–Wed) or Monday (Thu–Sun)</a:t>
-            </a:r>
-          </a:p>
-          <a:p>
-            <a:pPr algn="l"/>
-            <a:r>
-              <a:rPr sz="1150" b="0" i="0">
+              <a:t>• Get department-level counts delivered twice a week</a:t>
+            </a:r>
+          </a:p>
+          <a:p>
+            <a:pPr algn="l"/>
+            <a:r>
+              <a:rPr sz="1200" b="0" i="0">
                 <a:solidFill>
                   <a:srgbClr val="333344"/>
                 </a:solidFill>
                 <a:latin typeface="Segoe UI"/>
               </a:rPr>
-              <a:t>• Calendar popup with auto-highlighted batch range</a:t>
-            </a:r>
-          </a:p>
-          <a:p>
-            <a:pPr algn="l"/>
-            <a:r>
-              <a:rPr sz="1150" b="0" i="0">
+              <a:t>• Act on opportunities before competitors notice them</a:t>
+            </a:r>
+          </a:p>
+          <a:p>
+            <a:pPr algn="l"/>
+            <a:r>
+              <a:rPr sz="1200" b="0" i="0">
                 <a:solidFill>
                   <a:srgbClr val="333344"/>
                 </a:solidFill>
                 <a:latin typeface="Segoe UI"/>
               </a:rPr>
-              <a:t>• Live log output streamed to the screen while scraping</a:t>
+              <a:t>• Briefing dates and compulsory attendance flagged upfront</a:t>
             </a:r>
           </a:p>
         </p:txBody>
@@ -6579,8 +6611,8 @@
         </p:nvSpPr>
         <p:spPr>
           <a:xfrm>
-            <a:off x="4361688" y="1508760"/>
-            <a:ext cx="3566160" cy="1417320"/>
+            <a:off x="6309360" y="1508760"/>
+            <a:ext cx="5394960" cy="1508760"/>
           </a:xfrm>
           <a:prstGeom prst="rect">
             <a:avLst/>
@@ -6624,8 +6656,8 @@
         </p:nvSpPr>
         <p:spPr>
           <a:xfrm>
-            <a:off x="4361688" y="1508760"/>
-            <a:ext cx="50292" cy="1417320"/>
+            <a:off x="6309360" y="1508760"/>
+            <a:ext cx="50292" cy="1508760"/>
           </a:xfrm>
           <a:prstGeom prst="rect">
             <a:avLst/>
@@ -6667,8 +6699,8 @@
         </p:nvSpPr>
         <p:spPr>
           <a:xfrm>
-            <a:off x="4526280" y="1636776"/>
-            <a:ext cx="3364992" cy="1289304"/>
+            <a:off x="6473952" y="1636776"/>
+            <a:ext cx="5193792" cy="1380744"/>
           </a:xfrm>
           <a:prstGeom prst="rect">
             <a:avLst/>
@@ -6683,61 +6715,61 @@
           <a:p>
             <a:pPr algn="l"/>
             <a:r>
-              <a:rPr sz="1350" b="1">
+              <a:rPr sz="1400" b="1">
                 <a:solidFill>
                   <a:srgbClr val="1C3880"/>
                 </a:solidFill>
                 <a:latin typeface="Segoe UI"/>
               </a:rPr>
-              <a:t>Intelligent batch picker</a:t>
-            </a:r>
-          </a:p>
-          <a:p>
-            <a:pPr algn="l"/>
-            <a:r>
-              <a:rPr sz="1150" b="0" i="0">
+              <a:t>Procurement Intelligence Teams</a:t>
+            </a:r>
+          </a:p>
+          <a:p>
+            <a:pPr algn="l"/>
+            <a:r>
+              <a:rPr sz="1200" b="0" i="0">
                 <a:solidFill>
                   <a:srgbClr val="333344"/>
                 </a:solidFill>
                 <a:latin typeface="Segoe UI"/>
               </a:rPr>
-              <a:t>• Click any date in the week — correct range selected automatically</a:t>
-            </a:r>
-          </a:p>
-          <a:p>
-            <a:pPr algn="l"/>
-            <a:r>
-              <a:rPr sz="1150" b="0" i="0">
+              <a:t>• Track tender volumes across 26 organs of state</a:t>
+            </a:r>
+          </a:p>
+          <a:p>
+            <a:pPr algn="l"/>
+            <a:r>
+              <a:rPr sz="1200" b="0" i="0">
                 <a:solidFill>
                   <a:srgbClr val="333344"/>
                 </a:solidFill>
                 <a:latin typeface="Segoe UI"/>
               </a:rPr>
-              <a:t>• Previous / next week navigation arrows</a:t>
-            </a:r>
-          </a:p>
-          <a:p>
-            <a:pPr algn="l"/>
-            <a:r>
-              <a:rPr sz="1150" b="0" i="0">
+              <a:t>• Identify patterns — which departments are most active</a:t>
+            </a:r>
+          </a:p>
+          <a:p>
+            <a:pPr algn="l"/>
+            <a:r>
+              <a:rPr sz="1200" b="0" i="0">
                 <a:solidFill>
                   <a:srgbClr val="333344"/>
                 </a:solidFill>
                 <a:latin typeface="Segoe UI"/>
               </a:rPr>
-              <a:t>• Batch label displayed in human-readable format</a:t>
-            </a:r>
-          </a:p>
-          <a:p>
-            <a:pPr algn="l"/>
-            <a:r>
-              <a:rPr sz="1150" b="0" i="0">
+              <a:t>• Compare ICT vs RFQ ratios across reporting periods</a:t>
+            </a:r>
+          </a:p>
+          <a:p>
+            <a:pPr algn="l"/>
+            <a:r>
+              <a:rPr sz="1200" b="0" i="0">
                 <a:solidFill>
                   <a:srgbClr val="333344"/>
                 </a:solidFill>
                 <a:latin typeface="Segoe UI"/>
               </a:rPr>
-              <a:t>• Batch type suggested automatically based on today's day</a:t>
+              <a:t>• Historical 6-batch rolling view for trend analysis</a:t>
             </a:r>
           </a:p>
         </p:txBody>
@@ -6750,8 +6782,8 @@
         </p:nvSpPr>
         <p:spPr>
           <a:xfrm>
-            <a:off x="8311896" y="1508760"/>
-            <a:ext cx="3566160" cy="1417320"/>
+            <a:off x="411480" y="3154680"/>
+            <a:ext cx="5394960" cy="1508760"/>
           </a:xfrm>
           <a:prstGeom prst="rect">
             <a:avLst/>
@@ -6795,8 +6827,8 @@
         </p:nvSpPr>
         <p:spPr>
           <a:xfrm>
-            <a:off x="8311896" y="1508760"/>
-            <a:ext cx="50292" cy="1417320"/>
+            <a:off x="411480" y="3154680"/>
+            <a:ext cx="50292" cy="1508760"/>
           </a:xfrm>
           <a:prstGeom prst="rect">
             <a:avLst/>
@@ -6838,8 +6870,8 @@
         </p:nvSpPr>
         <p:spPr>
           <a:xfrm>
-            <a:off x="8476488" y="1636776"/>
-            <a:ext cx="3364992" cy="1289304"/>
+            <a:off x="576072" y="3282696"/>
+            <a:ext cx="5193792" cy="1380744"/>
           </a:xfrm>
           <a:prstGeom prst="rect">
             <a:avLst/>
@@ -6854,61 +6886,61 @@
           <a:p>
             <a:pPr algn="l"/>
             <a:r>
-              <a:rPr sz="1350" b="1">
+              <a:rPr sz="1400" b="1">
                 <a:solidFill>
                   <a:srgbClr val="1C3880"/>
                 </a:solidFill>
                 <a:latin typeface="Segoe UI"/>
               </a:rPr>
-              <a:t>Structured Excel output</a:t>
-            </a:r>
-          </a:p>
-          <a:p>
-            <a:pPr algn="l"/>
-            <a:r>
-              <a:rPr sz="1150" b="0" i="0">
+              <a:t>Executive Reporting</a:t>
+            </a:r>
+          </a:p>
+          <a:p>
+            <a:pPr algn="l"/>
+            <a:r>
+              <a:rPr sz="1200" b="0" i="0">
                 <a:solidFill>
                   <a:srgbClr val="333344"/>
                 </a:solidFill>
                 <a:latin typeface="Segoe UI"/>
               </a:rPr>
-              <a:t>• Per-day files in batches/ subfolder</a:t>
-            </a:r>
-          </a:p>
-          <a:p>
-            <a:pPr algn="l"/>
-            <a:r>
-              <a:rPr sz="1150" b="0" i="0">
+              <a:t>• Clean, audit-ready Excel reports every batch cycle</a:t>
+            </a:r>
+          </a:p>
+          <a:p>
+            <a:pPr algn="l"/>
+            <a:r>
+              <a:rPr sz="1200" b="0" i="0">
                 <a:solidFill>
                   <a:srgbClr val="333344"/>
                 </a:solidFill>
                 <a:latin typeface="Segoe UI"/>
               </a:rPr>
-              <a:t>• Combined end-product file with Tender Data + Final tabs</a:t>
-            </a:r>
-          </a:p>
-          <a:p>
-            <a:pPr algn="l"/>
-            <a:r>
-              <a:rPr sz="1150" b="0" i="0">
+              <a:t>• Summary counts ready to paste into board packs</a:t>
+            </a:r>
+          </a:p>
+          <a:p>
+            <a:pPr algn="l"/>
+            <a:r>
+              <a:rPr sz="1200" b="0" i="0">
                 <a:solidFill>
                   <a:srgbClr val="333344"/>
                 </a:solidFill>
                 <a:latin typeface="Segoe UI"/>
               </a:rPr>
-              <a:t>• Tender Summary — one tab per department with any tenders (RFQs first)</a:t>
-            </a:r>
-          </a:p>
-          <a:p>
-            <a:pPr algn="l"/>
-            <a:r>
-              <a:rPr sz="1150" b="0" i="0">
+              <a:t>• Consistent format — same layout every time</a:t>
+            </a:r>
+          </a:p>
+          <a:p>
+            <a:pPr algn="l"/>
+            <a:r>
+              <a:rPr sz="1200" b="0" i="0">
                 <a:solidFill>
                   <a:srgbClr val="333344"/>
                 </a:solidFill>
                 <a:latin typeface="Segoe UI"/>
               </a:rPr>
-              <a:t>• Clickable hyperlinks to source documents</a:t>
+              <a:t>• No manual work between portal and report</a:t>
             </a:r>
           </a:p>
         </p:txBody>
@@ -6921,8 +6953,8 @@
         </p:nvSpPr>
         <p:spPr>
           <a:xfrm>
-            <a:off x="411480" y="3090672"/>
-            <a:ext cx="3566160" cy="1417320"/>
+            <a:off x="6309360" y="3154680"/>
+            <a:ext cx="5394960" cy="1508760"/>
           </a:xfrm>
           <a:prstGeom prst="rect">
             <a:avLst/>
@@ -6966,8 +6998,8 @@
         </p:nvSpPr>
         <p:spPr>
           <a:xfrm>
-            <a:off x="411480" y="3090672"/>
-            <a:ext cx="50292" cy="1417320"/>
+            <a:off x="6309360" y="3154680"/>
+            <a:ext cx="50292" cy="1508760"/>
           </a:xfrm>
           <a:prstGeom prst="rect">
             <a:avLst/>
@@ -7009,8 +7041,8 @@
         </p:nvSpPr>
         <p:spPr>
           <a:xfrm>
-            <a:off x="576072" y="3218688"/>
-            <a:ext cx="3364992" cy="1289304"/>
+            <a:off x="6473952" y="3282696"/>
+            <a:ext cx="5193792" cy="1380744"/>
           </a:xfrm>
           <a:prstGeom prst="rect">
             <a:avLst/>
@@ -7025,403 +7057,61 @@
           <a:p>
             <a:pPr algn="l"/>
             <a:r>
-              <a:rPr sz="1350" b="1">
+              <a:rPr sz="1400" b="1">
                 <a:solidFill>
                   <a:srgbClr val="1C3880"/>
                 </a:solidFill>
                 <a:latin typeface="Segoe UI"/>
               </a:rPr>
-              <a:t>Equation file management</a:t>
-            </a:r>
-          </a:p>
-          <a:p>
-            <a:pPr algn="l"/>
-            <a:r>
-              <a:rPr sz="1150" b="0" i="0">
+              <a:t>Compliance &amp; Supplier Development</a:t>
+            </a:r>
+          </a:p>
+          <a:p>
+            <a:pPr algn="l"/>
+            <a:r>
+              <a:rPr sz="1200" b="0" i="0">
                 <a:solidFill>
                   <a:srgbClr val="333344"/>
                 </a:solidFill>
                 <a:latin typeface="Segoe UI"/>
               </a:rPr>
-              <a:t>• New batch inserted at column B (left-most position)</a:t>
-            </a:r>
-          </a:p>
-          <a:p>
-            <a:pPr algn="l"/>
-            <a:r>
-              <a:rPr sz="1150" b="0" i="0">
+              <a:t>• Monitor tenders from specific municipalities and SOEs</a:t>
+            </a:r>
+          </a:p>
+          <a:p>
+            <a:pPr algn="l"/>
+            <a:r>
+              <a:rPr sz="1200" b="0" i="0">
                 <a:solidFill>
                   <a:srgbClr val="333344"/>
                 </a:solidFill>
                 <a:latin typeface="Segoe UI"/>
               </a:rPr>
-              <a:t>• Older batches shifted right automatically</a:t>
-            </a:r>
-          </a:p>
-          <a:p>
-            <a:pPr algn="l"/>
-            <a:r>
-              <a:rPr sz="1150" b="0" i="0">
+              <a:t>• Track closing dates to ensure timely submissions</a:t>
+            </a:r>
+          </a:p>
+          <a:p>
+            <a:pPr algn="l"/>
+            <a:r>
+              <a:rPr sz="1200" b="0" i="0">
                 <a:solidFill>
                   <a:srgbClr val="333344"/>
                 </a:solidFill>
                 <a:latin typeface="Segoe UI"/>
               </a:rPr>
-              <a:t>• Maximum 6 batches enforced — oldest removed</a:t>
-            </a:r>
-          </a:p>
-          <a:p>
-            <a:pPr algn="l"/>
-            <a:r>
-              <a:rPr sz="1150" b="0" i="0">
+              <a:t>• Identify compulsory briefing sessions in advance</a:t>
+            </a:r>
+          </a:p>
+          <a:p>
+            <a:pPr algn="l"/>
+            <a:r>
+              <a:rPr sz="1200" b="0" i="0">
                 <a:solidFill>
                   <a:srgbClr val="333344"/>
                 </a:solidFill>
                 <a:latin typeface="Segoe UI"/>
               </a:rPr>
-              <a:t>• File copied to batch's Display Equation/ folder</a:t>
-            </a:r>
-          </a:p>
-        </p:txBody>
-      </p:sp>
-      <p:sp>
-        <p:nvSpPr>
-          <p:cNvPr id="21" name="Rectangle 20"/>
-          <p:cNvSpPr/>
-          <p:nvPr/>
-        </p:nvSpPr>
-        <p:spPr>
-          <a:xfrm>
-            <a:off x="4361688" y="3090672"/>
-            <a:ext cx="3566160" cy="1417320"/>
-          </a:xfrm>
-          <a:prstGeom prst="rect">
-            <a:avLst/>
-          </a:prstGeom>
-          <a:solidFill>
-            <a:srgbClr val="F4F6FA"/>
-          </a:solidFill>
-          <a:ln w="9525">
-            <a:solidFill>
-              <a:srgbClr val="E0E4EE"/>
-            </a:solidFill>
-          </a:ln>
-        </p:spPr>
-        <p:style>
-          <a:lnRef idx="1">
-            <a:schemeClr val="accent1"/>
-          </a:lnRef>
-          <a:fillRef idx="3">
-            <a:schemeClr val="accent1"/>
-          </a:fillRef>
-          <a:effectRef idx="2">
-            <a:schemeClr val="accent1"/>
-          </a:effectRef>
-          <a:fontRef idx="minor">
-            <a:schemeClr val="lt1"/>
-          </a:fontRef>
-        </p:style>
-        <p:txBody>
-          <a:bodyPr rtlCol="0" anchor="ctr"/>
-          <a:lstStyle/>
-          <a:p>
-            <a:pPr algn="ctr"/>
-          </a:p>
-        </p:txBody>
-      </p:sp>
-      <p:sp>
-        <p:nvSpPr>
-          <p:cNvPr id="22" name="Rectangle 21"/>
-          <p:cNvSpPr/>
-          <p:nvPr/>
-        </p:nvSpPr>
-        <p:spPr>
-          <a:xfrm>
-            <a:off x="4361688" y="3090672"/>
-            <a:ext cx="50292" cy="1417320"/>
-          </a:xfrm>
-          <a:prstGeom prst="rect">
-            <a:avLst/>
-          </a:prstGeom>
-          <a:solidFill>
-            <a:srgbClr val="F5A000"/>
-          </a:solidFill>
-          <a:ln>
-            <a:noFill/>
-          </a:ln>
-        </p:spPr>
-        <p:style>
-          <a:lnRef idx="1">
-            <a:schemeClr val="accent1"/>
-          </a:lnRef>
-          <a:fillRef idx="3">
-            <a:schemeClr val="accent1"/>
-          </a:fillRef>
-          <a:effectRef idx="2">
-            <a:schemeClr val="accent1"/>
-          </a:effectRef>
-          <a:fontRef idx="minor">
-            <a:schemeClr val="lt1"/>
-          </a:fontRef>
-        </p:style>
-        <p:txBody>
-          <a:bodyPr rtlCol="0" anchor="ctr"/>
-          <a:lstStyle/>
-          <a:p>
-            <a:pPr algn="ctr"/>
-          </a:p>
-        </p:txBody>
-      </p:sp>
-      <p:sp>
-        <p:nvSpPr>
-          <p:cNvPr id="23" name="TextBox 22"/>
-          <p:cNvSpPr txBox="1"/>
-          <p:nvPr/>
-        </p:nvSpPr>
-        <p:spPr>
-          <a:xfrm>
-            <a:off x="4526280" y="3218688"/>
-            <a:ext cx="3364992" cy="1289304"/>
-          </a:xfrm>
-          <a:prstGeom prst="rect">
-            <a:avLst/>
-          </a:prstGeom>
-          <a:noFill/>
-        </p:spPr>
-        <p:txBody>
-          <a:bodyPr wrap="square">
-            <a:spAutoFit/>
-          </a:bodyPr>
-          <a:lstStyle/>
-          <a:p>
-            <a:pPr algn="l"/>
-            <a:r>
-              <a:rPr sz="1350" b="1">
-                <a:solidFill>
-                  <a:srgbClr val="1C3880"/>
-                </a:solidFill>
-                <a:latin typeface="Segoe UI"/>
-              </a:rPr>
-              <a:t>Robust scraping</a:t>
-            </a:r>
-          </a:p>
-          <a:p>
-            <a:pPr algn="l"/>
-            <a:r>
-              <a:rPr sz="1150" b="0" i="0">
-                <a:solidFill>
-                  <a:srgbClr val="333344"/>
-                </a:solidFill>
-                <a:latin typeface="Segoe UI"/>
-              </a:rPr>
-              <a:t>• Retry logic for stale elements and network errors</a:t>
-            </a:r>
-          </a:p>
-          <a:p>
-            <a:pPr algn="l"/>
-            <a:r>
-              <a:rPr sz="1150" b="0" i="0">
-                <a:solidFill>
-                  <a:srgbClr val="333344"/>
-                </a:solidFill>
-                <a:latin typeface="Segoe UI"/>
-              </a:rPr>
-              <a:t>• Automatic duplicate detection and filtering</a:t>
-            </a:r>
-          </a:p>
-          <a:p>
-            <a:pPr algn="l"/>
-            <a:r>
-              <a:rPr sz="1150" b="0" i="0">
-                <a:solidFill>
-                  <a:srgbClr val="333344"/>
-                </a:solidFill>
-                <a:latin typeface="Segoe UI"/>
-              </a:rPr>
-              <a:t>• pageLoadWait tuned for jQuery DataTable initialisation</a:t>
-            </a:r>
-          </a:p>
-          <a:p>
-            <a:pPr algn="l"/>
-            <a:r>
-              <a:rPr sz="1150" b="0" i="0">
-                <a:solidFill>
-                  <a:srgbClr val="333344"/>
-                </a:solidFill>
-                <a:latin typeface="Segoe UI"/>
-              </a:rPr>
-              <a:t>• 25 tracked departments / organs of state</a:t>
-            </a:r>
-          </a:p>
-        </p:txBody>
-      </p:sp>
-      <p:sp>
-        <p:nvSpPr>
-          <p:cNvPr id="24" name="Rectangle 23"/>
-          <p:cNvSpPr/>
-          <p:nvPr/>
-        </p:nvSpPr>
-        <p:spPr>
-          <a:xfrm>
-            <a:off x="8311896" y="3090672"/>
-            <a:ext cx="3566160" cy="1417320"/>
-          </a:xfrm>
-          <a:prstGeom prst="rect">
-            <a:avLst/>
-          </a:prstGeom>
-          <a:solidFill>
-            <a:srgbClr val="F4F6FA"/>
-          </a:solidFill>
-          <a:ln w="9525">
-            <a:solidFill>
-              <a:srgbClr val="E0E4EE"/>
-            </a:solidFill>
-          </a:ln>
-        </p:spPr>
-        <p:style>
-          <a:lnRef idx="1">
-            <a:schemeClr val="accent1"/>
-          </a:lnRef>
-          <a:fillRef idx="3">
-            <a:schemeClr val="accent1"/>
-          </a:fillRef>
-          <a:effectRef idx="2">
-            <a:schemeClr val="accent1"/>
-          </a:effectRef>
-          <a:fontRef idx="minor">
-            <a:schemeClr val="lt1"/>
-          </a:fontRef>
-        </p:style>
-        <p:txBody>
-          <a:bodyPr rtlCol="0" anchor="ctr"/>
-          <a:lstStyle/>
-          <a:p>
-            <a:pPr algn="ctr"/>
-          </a:p>
-        </p:txBody>
-      </p:sp>
-      <p:sp>
-        <p:nvSpPr>
-          <p:cNvPr id="25" name="Rectangle 24"/>
-          <p:cNvSpPr/>
-          <p:nvPr/>
-        </p:nvSpPr>
-        <p:spPr>
-          <a:xfrm>
-            <a:off x="8311896" y="3090672"/>
-            <a:ext cx="50292" cy="1417320"/>
-          </a:xfrm>
-          <a:prstGeom prst="rect">
-            <a:avLst/>
-          </a:prstGeom>
-          <a:solidFill>
-            <a:srgbClr val="F5A000"/>
-          </a:solidFill>
-          <a:ln>
-            <a:noFill/>
-          </a:ln>
-        </p:spPr>
-        <p:style>
-          <a:lnRef idx="1">
-            <a:schemeClr val="accent1"/>
-          </a:lnRef>
-          <a:fillRef idx="3">
-            <a:schemeClr val="accent1"/>
-          </a:fillRef>
-          <a:effectRef idx="2">
-            <a:schemeClr val="accent1"/>
-          </a:effectRef>
-          <a:fontRef idx="minor">
-            <a:schemeClr val="lt1"/>
-          </a:fontRef>
-        </p:style>
-        <p:txBody>
-          <a:bodyPr rtlCol="0" anchor="ctr"/>
-          <a:lstStyle/>
-          <a:p>
-            <a:pPr algn="ctr"/>
-          </a:p>
-        </p:txBody>
-      </p:sp>
-      <p:sp>
-        <p:nvSpPr>
-          <p:cNvPr id="26" name="TextBox 25"/>
-          <p:cNvSpPr txBox="1"/>
-          <p:nvPr/>
-        </p:nvSpPr>
-        <p:spPr>
-          <a:xfrm>
-            <a:off x="8476488" y="3218688"/>
-            <a:ext cx="3364992" cy="1289304"/>
-          </a:xfrm>
-          <a:prstGeom prst="rect">
-            <a:avLst/>
-          </a:prstGeom>
-          <a:noFill/>
-        </p:spPr>
-        <p:txBody>
-          <a:bodyPr wrap="square">
-            <a:spAutoFit/>
-          </a:bodyPr>
-          <a:lstStyle/>
-          <a:p>
-            <a:pPr algn="l"/>
-            <a:r>
-              <a:rPr sz="1350" b="1">
-                <a:solidFill>
-                  <a:srgbClr val="1C3880"/>
-                </a:solidFill>
-                <a:latin typeface="Segoe UI"/>
-              </a:rPr>
-              <a:t>Organised folder structure</a:t>
-            </a:r>
-          </a:p>
-          <a:p>
-            <a:pPr algn="l"/>
-            <a:r>
-              <a:rPr sz="1150" b="0" i="0">
-                <a:solidFill>
-                  <a:srgbClr val="333344"/>
-                </a:solidFill>
-                <a:latin typeface="Segoe UI"/>
-              </a:rPr>
-              <a:t>• data/(T) DD-DD Mon YYYY/ named per batch</a:t>
-            </a:r>
-          </a:p>
-          <a:p>
-            <a:pPr algn="l"/>
-            <a:r>
-              <a:rPr sz="1150" b="0" i="0">
-                <a:solidFill>
-                  <a:srgbClr val="333344"/>
-                </a:solidFill>
-                <a:latin typeface="Segoe UI"/>
-              </a:rPr>
-              <a:t>• Three subfolders: batches/, end product/, Display Equation/</a:t>
-            </a:r>
-          </a:p>
-          <a:p>
-            <a:pPr algn="l"/>
-            <a:r>
-              <a:rPr sz="1150" b="0" i="0">
-                <a:solidFill>
-                  <a:srgbClr val="333344"/>
-                </a:solidFill>
-                <a:latin typeface="Segoe UI"/>
-              </a:rPr>
-              <a:t>• Scraper log written to logs/scraper.log</a:t>
-            </a:r>
-          </a:p>
-          <a:p>
-            <a:pPr algn="l"/>
-            <a:r>
-              <a:rPr sz="1150" b="0" i="0">
-                <a:solidFill>
-                  <a:srgbClr val="333344"/>
-                </a:solidFill>
-                <a:latin typeface="Segoe UI"/>
-              </a:rPr>
-              <a:t>• OneDrive sync keeps equation file up to date</a:t>
+              <a:t>• Province-level visibility for targeted follow-up</a:t>
             </a:r>
           </a:p>
         </p:txBody>
@@ -7595,7 +7285,7 @@
                 </a:solidFill>
                 <a:latin typeface="Segoe UI"/>
               </a:rPr>
-              <a:t>Five steps from launch to ready-to-present output</a:t>
+              <a:t>From launch to ready-to-present output in minutes</a:t>
             </a:r>
           </a:p>
         </p:txBody>
@@ -7673,7 +7363,7 @@
                 </a:solidFill>
                 <a:latin typeface="Segoe UI"/>
               </a:rPr>
-              <a:t>Amidel (Pty) Ltd  |  Beyond Technology  |  eTender Scraper</a:t>
+              <a:t>Amidel (Pty) Ltd  |  Beyond Technology  |  Tender Intelligence</a:t>
             </a:r>
           </a:p>
         </p:txBody>
@@ -7864,7 +7554,7 @@
                 </a:solidFill>
                 <a:latin typeface="Segoe UI"/>
               </a:rPr>
-              <a:t>Pick Batch</a:t>
+              <a:t>Select Period</a:t>
             </a:r>
           </a:p>
         </p:txBody>
@@ -7899,7 +7589,7 @@
                 </a:solidFill>
                 <a:latin typeface="Segoe UI"/>
               </a:rPr>
-              <a:t>Select batch type (T/M) and click any date in the target week. The app calculates the correct Mon–Wed or Thu–Sun range.</a:t>
+              <a:t>Choose the reporting period (Mon–Wed or Thu–Sun) using the calendar. The correct date range is set automatically.</a:t>
             </a:r>
           </a:p>
         </p:txBody>
@@ -8090,7 +7780,7 @@
                 </a:solidFill>
                 <a:latin typeface="Segoe UI"/>
               </a:rPr>
-              <a:t>Run Scraper</a:t>
+              <a:t>Run</a:t>
             </a:r>
           </a:p>
         </p:txBody>
@@ -8125,7 +7815,7 @@
                 </a:solidFill>
                 <a:latin typeface="Segoe UI"/>
               </a:rPr>
-              <a:t>Click Run Scraper. Selenium opens Chrome and visits etenders.gov.za for each day in the range.</a:t>
+              <a:t>Click Run. The scraper visits etenders.gov.za for each day in the period and collects all tender listings.</a:t>
             </a:r>
           </a:p>
         </p:txBody>
@@ -8316,7 +8006,7 @@
                 </a:solidFill>
                 <a:latin typeface="Segoe UI"/>
               </a:rPr>
-              <a:t>Extract Data</a:t>
+              <a:t>Extract</a:t>
             </a:r>
           </a:p>
         </p:txBody>
@@ -8351,7 +8041,7 @@
                 </a:solidFill>
                 <a:latin typeface="Segoe UI"/>
               </a:rPr>
-              <a:t>Each tender row is expanded, all 23 fields are read, and duplicates are filtered before saving.</a:t>
+              <a:t>Every tender's details are captured — description, department, type, closing date, briefing info, and more.</a:t>
             </a:r>
           </a:p>
         </p:txBody>
@@ -8542,7 +8232,7 @@
                 </a:solidFill>
                 <a:latin typeface="Segoe UI"/>
               </a:rPr>
-              <a:t>Build Outputs</a:t>
+              <a:t>Report</a:t>
             </a:r>
           </a:p>
         </p:txBody>
@@ -8577,7 +8267,7 @@
                 </a:solidFill>
                 <a:latin typeface="Segoe UI"/>
               </a:rPr>
-              <a:t>Per-day Excel files are saved, then merged into the RFQ_and_ICT_Checker workbook and Tender Summary.</a:t>
+              <a:t>Per-day files are saved, then combined into the RFQ &amp; ICT Checker and the department Tender Summary.</a:t>
             </a:r>
           </a:p>
         </p:txBody>
@@ -8768,7 +8458,7 @@
                 </a:solidFill>
                 <a:latin typeface="Segoe UI"/>
               </a:rPr>
-              <a:t>Update Equation</a:t>
+              <a:t>Track</a:t>
             </a:r>
           </a:p>
         </p:txBody>
@@ -8803,7 +8493,7 @@
                 </a:solidFill>
                 <a:latin typeface="Segoe UI"/>
               </a:rPr>
-              <a:t>The equation file is updated with the new batch counts, saved, and copied to the Display Equation/ folder.</a:t>
+              <a:t>The rolling tracker is updated with the new period's counts and saved — ready to share immediately.</a:t>
             </a:r>
           </a:p>
         </p:txBody>
@@ -8942,7 +8632,7 @@
                 </a:solidFill>
                 <a:latin typeface="Segoe UI"/>
               </a:rPr>
-              <a:t>Output Structure</a:t>
+              <a:t>What You Receive</a:t>
             </a:r>
           </a:p>
         </p:txBody>
@@ -8977,7 +8667,7 @@
                 </a:solidFill>
                 <a:latin typeface="Segoe UI"/>
               </a:rPr>
-              <a:t>Everything you need, exactly where you expect it</a:t>
+              <a:t>Structured, consistent reports delivered after every run</a:t>
             </a:r>
           </a:p>
         </p:txBody>
@@ -9055,7 +8745,7 @@
                 </a:solidFill>
                 <a:latin typeface="Segoe UI"/>
               </a:rPr>
-              <a:t>Amidel (Pty) Ltd  |  Beyond Technology  |  eTender Scraper</a:t>
+              <a:t>Amidel (Pty) Ltd  |  Beyond Technology  |  Tender Intelligence</a:t>
             </a:r>
           </a:p>
         </p:txBody>
@@ -9103,17 +8793,19 @@
         </p:nvSpPr>
         <p:spPr>
           <a:xfrm>
-            <a:off x="457200" y="1600200"/>
-            <a:ext cx="5120640" cy="4846320"/>
-          </a:xfrm>
-          <a:prstGeom prst="rect">
-            <a:avLst/>
-          </a:prstGeom>
-          <a:solidFill>
-            <a:srgbClr val="1A1A2E"/>
-          </a:solidFill>
-          <a:ln>
-            <a:noFill/>
+            <a:off x="457200" y="1508760"/>
+            <a:ext cx="11247120" cy="914400"/>
+          </a:xfrm>
+          <a:prstGeom prst="rect">
+            <a:avLst/>
+          </a:prstGeom>
+          <a:solidFill>
+            <a:srgbClr val="F4F6FA"/>
+          </a:solidFill>
+          <a:ln w="6350">
+            <a:solidFill>
+              <a:srgbClr val="E0E4EE"/>
+            </a:solidFill>
           </a:ln>
         </p:spPr>
         <p:style>
@@ -9140,14 +8832,100 @@
       </p:sp>
       <p:sp>
         <p:nvSpPr>
-          <p:cNvPr id="10" name="TextBox 9"/>
+          <p:cNvPr id="10" name="Rectangle 9"/>
+          <p:cNvSpPr/>
+          <p:nvPr/>
+        </p:nvSpPr>
+        <p:spPr>
+          <a:xfrm>
+            <a:off x="457200" y="1508760"/>
+            <a:ext cx="45720" cy="914400"/>
+          </a:xfrm>
+          <a:prstGeom prst="rect">
+            <a:avLst/>
+          </a:prstGeom>
+          <a:solidFill>
+            <a:srgbClr val="F5A000"/>
+          </a:solidFill>
+          <a:ln>
+            <a:noFill/>
+          </a:ln>
+        </p:spPr>
+        <p:style>
+          <a:lnRef idx="1">
+            <a:schemeClr val="accent1"/>
+          </a:lnRef>
+          <a:fillRef idx="3">
+            <a:schemeClr val="accent1"/>
+          </a:fillRef>
+          <a:effectRef idx="2">
+            <a:schemeClr val="accent1"/>
+          </a:effectRef>
+          <a:fontRef idx="minor">
+            <a:schemeClr val="lt1"/>
+          </a:fontRef>
+        </p:style>
+        <p:txBody>
+          <a:bodyPr rtlCol="0" anchor="ctr"/>
+          <a:lstStyle/>
+          <a:p>
+            <a:pPr algn="ctr"/>
+          </a:p>
+        </p:txBody>
+      </p:sp>
+      <p:sp>
+        <p:nvSpPr>
+          <p:cNvPr id="11" name="Rectangle 10"/>
+          <p:cNvSpPr/>
+          <p:nvPr/>
+        </p:nvSpPr>
+        <p:spPr>
+          <a:xfrm>
+            <a:off x="594360" y="1773936"/>
+            <a:ext cx="329184" cy="329184"/>
+          </a:xfrm>
+          <a:prstGeom prst="rect">
+            <a:avLst/>
+          </a:prstGeom>
+          <a:solidFill>
+            <a:srgbClr val="1C3880"/>
+          </a:solidFill>
+          <a:ln>
+            <a:noFill/>
+          </a:ln>
+        </p:spPr>
+        <p:style>
+          <a:lnRef idx="1">
+            <a:schemeClr val="accent1"/>
+          </a:lnRef>
+          <a:fillRef idx="3">
+            <a:schemeClr val="accent1"/>
+          </a:fillRef>
+          <a:effectRef idx="2">
+            <a:schemeClr val="accent1"/>
+          </a:effectRef>
+          <a:fontRef idx="minor">
+            <a:schemeClr val="lt1"/>
+          </a:fontRef>
+        </p:style>
+        <p:txBody>
+          <a:bodyPr rtlCol="0" anchor="ctr"/>
+          <a:lstStyle/>
+          <a:p>
+            <a:pPr algn="ctr"/>
+          </a:p>
+        </p:txBody>
+      </p:sp>
+      <p:sp>
+        <p:nvSpPr>
+          <p:cNvPr id="12" name="TextBox 11"/>
           <p:cNvSpPr txBox="1"/>
           <p:nvPr/>
         </p:nvSpPr>
         <p:spPr>
           <a:xfrm>
-            <a:off x="640080" y="1783080"/>
-            <a:ext cx="4846320" cy="4572000"/>
+            <a:off x="594360" y="1764792"/>
+            <a:ext cx="329184" cy="329184"/>
           </a:xfrm>
           <a:prstGeom prst="rect">
             <a:avLst/>
@@ -9160,42 +8938,99 @@
           </a:bodyPr>
           <a:lstStyle/>
           <a:p>
-            <a:pPr algn="l"/>
-            <a:r>
-              <a:rPr sz="1200" b="0" i="0">
-                <a:solidFill>
-                  <a:srgbClr val="C8D0E0"/>
-                </a:solidFill>
-                <a:latin typeface="Consolas"/>
-              </a:rPr>
-              <a:t>data/
-└── (T) 19-21 May 2026/
-    ├── batches/
-    │   ├── tenders_2026_05_19.xlsx
-    │   ├── tenders_2026_05_20.xlsx
-    │   └── tenders_2026_05_21.xlsx
-    ├── end product/
-    │   └── RFQ_and_ICT_Checker
-    │       _(19 - 21 May).xlsx
-    ├── Display Equation/
-    │   └── RFQ_and_ICT_Equation.xlsx
-    └── Tender Summary.xlsx
-logs/
-└── scraper.log</a:t>
-            </a:r>
-          </a:p>
-        </p:txBody>
-      </p:sp>
-      <p:sp>
-        <p:nvSpPr>
-          <p:cNvPr id="11" name="Rectangle 10"/>
+            <a:pPr algn="ctr"/>
+            <a:r>
+              <a:rPr sz="1200" b="1" i="0">
+                <a:solidFill>
+                  <a:srgbClr val="FFFFFF"/>
+                </a:solidFill>
+                <a:latin typeface="Segoe UI"/>
+              </a:rPr>
+              <a:t>1</a:t>
+            </a:r>
+          </a:p>
+        </p:txBody>
+      </p:sp>
+      <p:sp>
+        <p:nvSpPr>
+          <p:cNvPr id="13" name="TextBox 12"/>
+          <p:cNvSpPr txBox="1"/>
+          <p:nvPr/>
+        </p:nvSpPr>
+        <p:spPr>
+          <a:xfrm>
+            <a:off x="1051560" y="1581912"/>
+            <a:ext cx="2194560" cy="320040"/>
+          </a:xfrm>
+          <a:prstGeom prst="rect">
+            <a:avLst/>
+          </a:prstGeom>
+          <a:noFill/>
+        </p:spPr>
+        <p:txBody>
+          <a:bodyPr wrap="square">
+            <a:spAutoFit/>
+          </a:bodyPr>
+          <a:lstStyle/>
+          <a:p>
+            <a:pPr algn="l"/>
+            <a:r>
+              <a:rPr sz="1200" b="1" i="0">
+                <a:solidFill>
+                  <a:srgbClr val="1C3880"/>
+                </a:solidFill>
+                <a:latin typeface="Segoe UI"/>
+              </a:rPr>
+              <a:t>RFQ &amp; ICT Checker</a:t>
+            </a:r>
+          </a:p>
+        </p:txBody>
+      </p:sp>
+      <p:sp>
+        <p:nvSpPr>
+          <p:cNvPr id="14" name="TextBox 13"/>
+          <p:cNvSpPr txBox="1"/>
+          <p:nvPr/>
+        </p:nvSpPr>
+        <p:spPr>
+          <a:xfrm>
+            <a:off x="1051560" y="1892808"/>
+            <a:ext cx="10561320" cy="457200"/>
+          </a:xfrm>
+          <a:prstGeom prst="rect">
+            <a:avLst/>
+          </a:prstGeom>
+          <a:noFill/>
+        </p:spPr>
+        <p:txBody>
+          <a:bodyPr wrap="square">
+            <a:spAutoFit/>
+          </a:bodyPr>
+          <a:lstStyle/>
+          <a:p>
+            <a:pPr algn="l"/>
+            <a:r>
+              <a:rPr sz="1050" b="0" i="0">
+                <a:solidFill>
+                  <a:srgbClr val="333344"/>
+                </a:solidFill>
+                <a:latin typeface="Segoe UI"/>
+              </a:rPr>
+              <a:t>The primary report — all tenders for the period in one workbook. Includes a full data tab and a summary tab with counts broken down by department, ICT category, and tender type.</a:t>
+            </a:r>
+          </a:p>
+        </p:txBody>
+      </p:sp>
+      <p:sp>
+        <p:nvSpPr>
+          <p:cNvPr id="15" name="Rectangle 14"/>
           <p:cNvSpPr/>
           <p:nvPr/>
         </p:nvSpPr>
         <p:spPr>
           <a:xfrm>
-            <a:off x="5989320" y="1600200"/>
-            <a:ext cx="5833872" cy="859536"/>
+            <a:off x="457200" y="2532888"/>
+            <a:ext cx="11247120" cy="914400"/>
           </a:xfrm>
           <a:prstGeom prst="rect">
             <a:avLst/>
@@ -9233,14 +9068,14 @@
       </p:sp>
       <p:sp>
         <p:nvSpPr>
-          <p:cNvPr id="12" name="Rectangle 11"/>
+          <p:cNvPr id="16" name="Rectangle 15"/>
           <p:cNvSpPr/>
           <p:nvPr/>
         </p:nvSpPr>
         <p:spPr>
           <a:xfrm>
-            <a:off x="5989320" y="1600200"/>
-            <a:ext cx="45720" cy="859536"/>
+            <a:off x="457200" y="2532888"/>
+            <a:ext cx="45720" cy="914400"/>
           </a:xfrm>
           <a:prstGeom prst="rect">
             <a:avLst/>
@@ -9276,14 +9111,57 @@
       </p:sp>
       <p:sp>
         <p:nvSpPr>
-          <p:cNvPr id="13" name="TextBox 12"/>
+          <p:cNvPr id="17" name="Rectangle 16"/>
+          <p:cNvSpPr/>
+          <p:nvPr/>
+        </p:nvSpPr>
+        <p:spPr>
+          <a:xfrm>
+            <a:off x="594360" y="2798064"/>
+            <a:ext cx="329184" cy="329184"/>
+          </a:xfrm>
+          <a:prstGeom prst="rect">
+            <a:avLst/>
+          </a:prstGeom>
+          <a:solidFill>
+            <a:srgbClr val="1C3880"/>
+          </a:solidFill>
+          <a:ln>
+            <a:noFill/>
+          </a:ln>
+        </p:spPr>
+        <p:style>
+          <a:lnRef idx="1">
+            <a:schemeClr val="accent1"/>
+          </a:lnRef>
+          <a:fillRef idx="3">
+            <a:schemeClr val="accent1"/>
+          </a:fillRef>
+          <a:effectRef idx="2">
+            <a:schemeClr val="accent1"/>
+          </a:effectRef>
+          <a:fontRef idx="minor">
+            <a:schemeClr val="lt1"/>
+          </a:fontRef>
+        </p:style>
+        <p:txBody>
+          <a:bodyPr rtlCol="0" anchor="ctr"/>
+          <a:lstStyle/>
+          <a:p>
+            <a:pPr algn="ctr"/>
+          </a:p>
+        </p:txBody>
+      </p:sp>
+      <p:sp>
+        <p:nvSpPr>
+          <p:cNvPr id="18" name="TextBox 17"/>
           <p:cNvSpPr txBox="1"/>
           <p:nvPr/>
         </p:nvSpPr>
         <p:spPr>
           <a:xfrm>
-            <a:off x="6126480" y="1655064"/>
-            <a:ext cx="5650992" cy="320040"/>
+            <a:off x="594360" y="2788920"/>
+            <a:ext cx="329184" cy="329184"/>
           </a:xfrm>
           <a:prstGeom prst="rect">
             <a:avLst/>
@@ -9296,29 +9174,29 @@
           </a:bodyPr>
           <a:lstStyle/>
           <a:p>
-            <a:pPr algn="l"/>
-            <a:r>
-              <a:rPr sz="1100" b="1" i="0">
-                <a:solidFill>
-                  <a:srgbClr val="1C3880"/>
-                </a:solidFill>
-                <a:latin typeface="Consolas"/>
-              </a:rPr>
-              <a:t>tenders_YYYY_MM_DD.xlsx</a:t>
-            </a:r>
-          </a:p>
-        </p:txBody>
-      </p:sp>
-      <p:sp>
-        <p:nvSpPr>
-          <p:cNvPr id="14" name="TextBox 13"/>
+            <a:pPr algn="ctr"/>
+            <a:r>
+              <a:rPr sz="1200" b="1" i="0">
+                <a:solidFill>
+                  <a:srgbClr val="FFFFFF"/>
+                </a:solidFill>
+                <a:latin typeface="Segoe UI"/>
+              </a:rPr>
+              <a:t>2</a:t>
+            </a:r>
+          </a:p>
+        </p:txBody>
+      </p:sp>
+      <p:sp>
+        <p:nvSpPr>
+          <p:cNvPr id="19" name="TextBox 18"/>
           <p:cNvSpPr txBox="1"/>
           <p:nvPr/>
         </p:nvSpPr>
         <p:spPr>
           <a:xfrm>
-            <a:off x="6126480" y="1965960"/>
-            <a:ext cx="5650992" cy="457200"/>
+            <a:off x="1051560" y="2606040"/>
+            <a:ext cx="2194560" cy="320040"/>
           </a:xfrm>
           <a:prstGeom prst="rect">
             <a:avLst/>
@@ -9333,27 +9211,62 @@
           <a:p>
             <a:pPr algn="l"/>
             <a:r>
+              <a:rPr sz="1200" b="1" i="0">
+                <a:solidFill>
+                  <a:srgbClr val="1C3880"/>
+                </a:solidFill>
+                <a:latin typeface="Segoe UI"/>
+              </a:rPr>
+              <a:t>Tender Summary</a:t>
+            </a:r>
+          </a:p>
+        </p:txBody>
+      </p:sp>
+      <p:sp>
+        <p:nvSpPr>
+          <p:cNvPr id="20" name="TextBox 19"/>
+          <p:cNvSpPr txBox="1"/>
+          <p:nvPr/>
+        </p:nvSpPr>
+        <p:spPr>
+          <a:xfrm>
+            <a:off x="1051560" y="2916936"/>
+            <a:ext cx="10561320" cy="457200"/>
+          </a:xfrm>
+          <a:prstGeom prst="rect">
+            <a:avLst/>
+          </a:prstGeom>
+          <a:noFill/>
+        </p:spPr>
+        <p:txBody>
+          <a:bodyPr wrap="square">
+            <a:spAutoFit/>
+          </a:bodyPr>
+          <a:lstStyle/>
+          <a:p>
+            <a:pPr algn="l"/>
+            <a:r>
               <a:rPr sz="1050" b="0" i="0">
                 <a:solidFill>
                   <a:srgbClr val="333344"/>
                 </a:solidFill>
                 <a:latin typeface="Segoe UI"/>
               </a:rPr>
-              <a:t>Raw tender data for a single day — one row per tender, all 23 columns, saved immediately after each day is scraped.</a:t>
-            </a:r>
-          </a:p>
-        </p:txBody>
-      </p:sp>
-      <p:sp>
-        <p:nvSpPr>
-          <p:cNvPr id="15" name="Rectangle 14"/>
+              <a:t>One tab per tracked department that had tenders in the period. RFQs are sorted to the top of each tab, followed by all other tender types ordered by closing date. Includes briefing date and whether attendance is compulsory.</a:t>
+            </a:r>
+          </a:p>
+        </p:txBody>
+      </p:sp>
+      <p:sp>
+        <p:nvSpPr>
+          <p:cNvPr id="21" name="Rectangle 20"/>
           <p:cNvSpPr/>
           <p:nvPr/>
         </p:nvSpPr>
         <p:spPr>
           <a:xfrm>
-            <a:off x="5989320" y="2569464"/>
-            <a:ext cx="5833872" cy="859536"/>
+            <a:off x="457200" y="3557016"/>
+            <a:ext cx="11247120" cy="914400"/>
           </a:xfrm>
           <a:prstGeom prst="rect">
             <a:avLst/>
@@ -9391,14 +9304,14 @@
       </p:sp>
       <p:sp>
         <p:nvSpPr>
-          <p:cNvPr id="16" name="Rectangle 15"/>
+          <p:cNvPr id="22" name="Rectangle 21"/>
           <p:cNvSpPr/>
           <p:nvPr/>
         </p:nvSpPr>
         <p:spPr>
           <a:xfrm>
-            <a:off x="5989320" y="2569464"/>
-            <a:ext cx="45720" cy="859536"/>
+            <a:off x="457200" y="3557016"/>
+            <a:ext cx="45720" cy="914400"/>
           </a:xfrm>
           <a:prstGeom prst="rect">
             <a:avLst/>
@@ -9434,14 +9347,57 @@
       </p:sp>
       <p:sp>
         <p:nvSpPr>
-          <p:cNvPr id="17" name="TextBox 16"/>
+          <p:cNvPr id="23" name="Rectangle 22"/>
+          <p:cNvSpPr/>
+          <p:nvPr/>
+        </p:nvSpPr>
+        <p:spPr>
+          <a:xfrm>
+            <a:off x="594360" y="3822192"/>
+            <a:ext cx="329184" cy="329184"/>
+          </a:xfrm>
+          <a:prstGeom prst="rect">
+            <a:avLst/>
+          </a:prstGeom>
+          <a:solidFill>
+            <a:srgbClr val="1C3880"/>
+          </a:solidFill>
+          <a:ln>
+            <a:noFill/>
+          </a:ln>
+        </p:spPr>
+        <p:style>
+          <a:lnRef idx="1">
+            <a:schemeClr val="accent1"/>
+          </a:lnRef>
+          <a:fillRef idx="3">
+            <a:schemeClr val="accent1"/>
+          </a:fillRef>
+          <a:effectRef idx="2">
+            <a:schemeClr val="accent1"/>
+          </a:effectRef>
+          <a:fontRef idx="minor">
+            <a:schemeClr val="lt1"/>
+          </a:fontRef>
+        </p:style>
+        <p:txBody>
+          <a:bodyPr rtlCol="0" anchor="ctr"/>
+          <a:lstStyle/>
+          <a:p>
+            <a:pPr algn="ctr"/>
+          </a:p>
+        </p:txBody>
+      </p:sp>
+      <p:sp>
+        <p:nvSpPr>
+          <p:cNvPr id="24" name="TextBox 23"/>
           <p:cNvSpPr txBox="1"/>
           <p:nvPr/>
         </p:nvSpPr>
         <p:spPr>
           <a:xfrm>
-            <a:off x="6126480" y="2624328"/>
-            <a:ext cx="5650992" cy="320040"/>
+            <a:off x="594360" y="3813048"/>
+            <a:ext cx="329184" cy="329184"/>
           </a:xfrm>
           <a:prstGeom prst="rect">
             <a:avLst/>
@@ -9454,29 +9410,29 @@
           </a:bodyPr>
           <a:lstStyle/>
           <a:p>
-            <a:pPr algn="l"/>
-            <a:r>
-              <a:rPr sz="1100" b="1" i="0">
-                <a:solidFill>
-                  <a:srgbClr val="1C3880"/>
-                </a:solidFill>
-                <a:latin typeface="Consolas"/>
-              </a:rPr>
-              <a:t>RFQ_and_ICT_Checker_(DD - DD Month).xlsx</a:t>
-            </a:r>
-          </a:p>
-        </p:txBody>
-      </p:sp>
-      <p:sp>
-        <p:nvSpPr>
-          <p:cNvPr id="18" name="TextBox 17"/>
+            <a:pPr algn="ctr"/>
+            <a:r>
+              <a:rPr sz="1200" b="1" i="0">
+                <a:solidFill>
+                  <a:srgbClr val="FFFFFF"/>
+                </a:solidFill>
+                <a:latin typeface="Segoe UI"/>
+              </a:rPr>
+              <a:t>3</a:t>
+            </a:r>
+          </a:p>
+        </p:txBody>
+      </p:sp>
+      <p:sp>
+        <p:nvSpPr>
+          <p:cNvPr id="25" name="TextBox 24"/>
           <p:cNvSpPr txBox="1"/>
           <p:nvPr/>
         </p:nvSpPr>
         <p:spPr>
           <a:xfrm>
-            <a:off x="6126480" y="2935224"/>
-            <a:ext cx="5650992" cy="457200"/>
+            <a:off x="1051560" y="3630168"/>
+            <a:ext cx="2194560" cy="320040"/>
           </a:xfrm>
           <a:prstGeom prst="rect">
             <a:avLst/>
@@ -9491,27 +9447,62 @@
           <a:p>
             <a:pPr algn="l"/>
             <a:r>
+              <a:rPr sz="1200" b="1" i="0">
+                <a:solidFill>
+                  <a:srgbClr val="1C3880"/>
+                </a:solidFill>
+                <a:latin typeface="Segoe UI"/>
+              </a:rPr>
+              <a:t>Per-Day Batch Files</a:t>
+            </a:r>
+          </a:p>
+        </p:txBody>
+      </p:sp>
+      <p:sp>
+        <p:nvSpPr>
+          <p:cNvPr id="26" name="TextBox 25"/>
+          <p:cNvSpPr txBox="1"/>
+          <p:nvPr/>
+        </p:nvSpPr>
+        <p:spPr>
+          <a:xfrm>
+            <a:off x="1051560" y="3941064"/>
+            <a:ext cx="10561320" cy="457200"/>
+          </a:xfrm>
+          <a:prstGeom prst="rect">
+            <a:avLst/>
+          </a:prstGeom>
+          <a:noFill/>
+        </p:spPr>
+        <p:txBody>
+          <a:bodyPr wrap="square">
+            <a:spAutoFit/>
+          </a:bodyPr>
+          <a:lstStyle/>
+          <a:p>
+            <a:pPr algn="l"/>
+            <a:r>
               <a:rPr sz="1050" b="0" i="0">
                 <a:solidFill>
                   <a:srgbClr val="333344"/>
                 </a:solidFill>
                 <a:latin typeface="Segoe UI"/>
               </a:rPr>
-              <a:t>Combined workbook: Tender Data tab (all tenders) + Final tab (COUNTIF formulas matching the equation file's source list).</a:t>
-            </a:r>
-          </a:p>
-        </p:txBody>
-      </p:sp>
-      <p:sp>
-        <p:nvSpPr>
-          <p:cNvPr id="19" name="Rectangle 18"/>
+              <a:t>Individual Excel files for each day in the reporting period. Useful for auditing or drilling into a specific day's activity without opening the combined file.</a:t>
+            </a:r>
+          </a:p>
+        </p:txBody>
+      </p:sp>
+      <p:sp>
+        <p:nvSpPr>
+          <p:cNvPr id="27" name="Rectangle 26"/>
           <p:cNvSpPr/>
           <p:nvPr/>
         </p:nvSpPr>
         <p:spPr>
           <a:xfrm>
-            <a:off x="5989320" y="3538728"/>
-            <a:ext cx="5833872" cy="859536"/>
+            <a:off x="457200" y="4581144"/>
+            <a:ext cx="11247120" cy="914400"/>
           </a:xfrm>
           <a:prstGeom prst="rect">
             <a:avLst/>
@@ -9549,14 +9540,14 @@
       </p:sp>
       <p:sp>
         <p:nvSpPr>
-          <p:cNvPr id="20" name="Rectangle 19"/>
+          <p:cNvPr id="28" name="Rectangle 27"/>
           <p:cNvSpPr/>
           <p:nvPr/>
         </p:nvSpPr>
         <p:spPr>
           <a:xfrm>
-            <a:off x="5989320" y="3538728"/>
-            <a:ext cx="45720" cy="859536"/>
+            <a:off x="457200" y="4581144"/>
+            <a:ext cx="45720" cy="914400"/>
           </a:xfrm>
           <a:prstGeom prst="rect">
             <a:avLst/>
@@ -9592,14 +9583,57 @@
       </p:sp>
       <p:sp>
         <p:nvSpPr>
-          <p:cNvPr id="21" name="TextBox 20"/>
+          <p:cNvPr id="29" name="Rectangle 28"/>
+          <p:cNvSpPr/>
+          <p:nvPr/>
+        </p:nvSpPr>
+        <p:spPr>
+          <a:xfrm>
+            <a:off x="594360" y="4846320"/>
+            <a:ext cx="329184" cy="329184"/>
+          </a:xfrm>
+          <a:prstGeom prst="rect">
+            <a:avLst/>
+          </a:prstGeom>
+          <a:solidFill>
+            <a:srgbClr val="1C3880"/>
+          </a:solidFill>
+          <a:ln>
+            <a:noFill/>
+          </a:ln>
+        </p:spPr>
+        <p:style>
+          <a:lnRef idx="1">
+            <a:schemeClr val="accent1"/>
+          </a:lnRef>
+          <a:fillRef idx="3">
+            <a:schemeClr val="accent1"/>
+          </a:fillRef>
+          <a:effectRef idx="2">
+            <a:schemeClr val="accent1"/>
+          </a:effectRef>
+          <a:fontRef idx="minor">
+            <a:schemeClr val="lt1"/>
+          </a:fontRef>
+        </p:style>
+        <p:txBody>
+          <a:bodyPr rtlCol="0" anchor="ctr"/>
+          <a:lstStyle/>
+          <a:p>
+            <a:pPr algn="ctr"/>
+          </a:p>
+        </p:txBody>
+      </p:sp>
+      <p:sp>
+        <p:nvSpPr>
+          <p:cNvPr id="30" name="TextBox 29"/>
           <p:cNvSpPr txBox="1"/>
           <p:nvPr/>
         </p:nvSpPr>
         <p:spPr>
           <a:xfrm>
-            <a:off x="6126480" y="3593592"/>
-            <a:ext cx="5650992" cy="320040"/>
+            <a:off x="594360" y="4837176"/>
+            <a:ext cx="329184" cy="329184"/>
           </a:xfrm>
           <a:prstGeom prst="rect">
             <a:avLst/>
@@ -9612,29 +9646,29 @@
           </a:bodyPr>
           <a:lstStyle/>
           <a:p>
-            <a:pPr algn="l"/>
-            <a:r>
-              <a:rPr sz="1100" b="1" i="0">
-                <a:solidFill>
-                  <a:srgbClr val="1C3880"/>
-                </a:solidFill>
-                <a:latin typeface="Consolas"/>
-              </a:rPr>
-              <a:t>Tender Summary.xlsx</a:t>
-            </a:r>
-          </a:p>
-        </p:txBody>
-      </p:sp>
-      <p:sp>
-        <p:nvSpPr>
-          <p:cNvPr id="22" name="TextBox 21"/>
+            <a:pPr algn="ctr"/>
+            <a:r>
+              <a:rPr sz="1200" b="1" i="0">
+                <a:solidFill>
+                  <a:srgbClr val="FFFFFF"/>
+                </a:solidFill>
+                <a:latin typeface="Segoe UI"/>
+              </a:rPr>
+              <a:t>4</a:t>
+            </a:r>
+          </a:p>
+        </p:txBody>
+      </p:sp>
+      <p:sp>
+        <p:nvSpPr>
+          <p:cNvPr id="31" name="TextBox 30"/>
           <p:cNvSpPr txBox="1"/>
           <p:nvPr/>
         </p:nvSpPr>
         <p:spPr>
           <a:xfrm>
-            <a:off x="6126480" y="3904488"/>
-            <a:ext cx="5650992" cy="457200"/>
+            <a:off x="1051560" y="4654296"/>
+            <a:ext cx="2194560" cy="320040"/>
           </a:xfrm>
           <a:prstGeom prst="rect">
             <a:avLst/>
@@ -9649,27 +9683,62 @@
           <a:p>
             <a:pPr algn="l"/>
             <a:r>
+              <a:rPr sz="1200" b="1" i="0">
+                <a:solidFill>
+                  <a:srgbClr val="1C3880"/>
+                </a:solidFill>
+                <a:latin typeface="Segoe UI"/>
+              </a:rPr>
+              <a:t>Rolling Tracker</a:t>
+            </a:r>
+          </a:p>
+        </p:txBody>
+      </p:sp>
+      <p:sp>
+        <p:nvSpPr>
+          <p:cNvPr id="32" name="TextBox 31"/>
+          <p:cNvSpPr txBox="1"/>
+          <p:nvPr/>
+        </p:nvSpPr>
+        <p:spPr>
+          <a:xfrm>
+            <a:off x="1051560" y="4965192"/>
+            <a:ext cx="10561320" cy="457200"/>
+          </a:xfrm>
+          <a:prstGeom prst="rect">
+            <a:avLst/>
+          </a:prstGeom>
+          <a:noFill/>
+        </p:spPr>
+        <p:txBody>
+          <a:bodyPr wrap="square">
+            <a:spAutoFit/>
+          </a:bodyPr>
+          <a:lstStyle/>
+          <a:p>
+            <a:pPr algn="l"/>
+            <a:r>
               <a:rPr sz="1050" b="0" i="0">
                 <a:solidFill>
                   <a:srgbClr val="333344"/>
                 </a:solidFill>
                 <a:latin typeface="Segoe UI"/>
               </a:rPr>
-              <a:t>One tab per tracked department that has any tenders. RFQs sort to the top; all other types sorted by closing date below.</a:t>
-            </a:r>
-          </a:p>
-        </p:txBody>
-      </p:sp>
-      <p:sp>
-        <p:nvSpPr>
-          <p:cNvPr id="23" name="Rectangle 22"/>
+              <a:t>A running comparison of NNT, ICT, and RFQ counts across the last six reporting periods — one column per batch, newest on the left. Automatically maintained and shared via OneDrive.</a:t>
+            </a:r>
+          </a:p>
+        </p:txBody>
+      </p:sp>
+      <p:sp>
+        <p:nvSpPr>
+          <p:cNvPr id="33" name="Rectangle 32"/>
           <p:cNvSpPr/>
           <p:nvPr/>
         </p:nvSpPr>
         <p:spPr>
           <a:xfrm>
-            <a:off x="5989320" y="4507992"/>
-            <a:ext cx="5833872" cy="859536"/>
+            <a:off x="457200" y="5605272"/>
+            <a:ext cx="11247120" cy="914400"/>
           </a:xfrm>
           <a:prstGeom prst="rect">
             <a:avLst/>
@@ -9707,14 +9776,14 @@
       </p:sp>
       <p:sp>
         <p:nvSpPr>
-          <p:cNvPr id="24" name="Rectangle 23"/>
+          <p:cNvPr id="34" name="Rectangle 33"/>
           <p:cNvSpPr/>
           <p:nvPr/>
         </p:nvSpPr>
         <p:spPr>
           <a:xfrm>
-            <a:off x="5989320" y="4507992"/>
-            <a:ext cx="45720" cy="859536"/>
+            <a:off x="457200" y="5605272"/>
+            <a:ext cx="45720" cy="914400"/>
           </a:xfrm>
           <a:prstGeom prst="rect">
             <a:avLst/>
@@ -9750,95 +9819,23 @@
       </p:sp>
       <p:sp>
         <p:nvSpPr>
-          <p:cNvPr id="25" name="TextBox 24"/>
-          <p:cNvSpPr txBox="1"/>
-          <p:nvPr/>
-        </p:nvSpPr>
-        <p:spPr>
-          <a:xfrm>
-            <a:off x="6126480" y="4562856"/>
-            <a:ext cx="5650992" cy="320040"/>
-          </a:xfrm>
-          <a:prstGeom prst="rect">
-            <a:avLst/>
-          </a:prstGeom>
-          <a:noFill/>
-        </p:spPr>
-        <p:txBody>
-          <a:bodyPr wrap="square">
-            <a:spAutoFit/>
-          </a:bodyPr>
-          <a:lstStyle/>
-          <a:p>
-            <a:pPr algn="l"/>
-            <a:r>
-              <a:rPr sz="1100" b="1" i="0">
-                <a:solidFill>
-                  <a:srgbClr val="1C3880"/>
-                </a:solidFill>
-                <a:latin typeface="Consolas"/>
-              </a:rPr>
-              <a:t>RFQ_and_ICT_Equation.xlsx  [Display Equation/]</a:t>
-            </a:r>
-          </a:p>
-        </p:txBody>
-      </p:sp>
-      <p:sp>
-        <p:nvSpPr>
-          <p:cNvPr id="26" name="TextBox 25"/>
-          <p:cNvSpPr txBox="1"/>
-          <p:nvPr/>
-        </p:nvSpPr>
-        <p:spPr>
-          <a:xfrm>
-            <a:off x="6126480" y="4873752"/>
-            <a:ext cx="5650992" cy="457200"/>
-          </a:xfrm>
-          <a:prstGeom prst="rect">
-            <a:avLst/>
-          </a:prstGeom>
-          <a:noFill/>
-        </p:spPr>
-        <p:txBody>
-          <a:bodyPr wrap="square">
-            <a:spAutoFit/>
-          </a:bodyPr>
-          <a:lstStyle/>
-          <a:p>
-            <a:pPr algn="l"/>
-            <a:r>
-              <a:rPr sz="1050" b="0" i="0">
-                <a:solidFill>
-                  <a:srgbClr val="333344"/>
-                </a:solidFill>
-                <a:latin typeface="Segoe UI"/>
-              </a:rPr>
-              <a:t>Rolling tracker of NNT / ICT / RFQ counts per source. Newest batch always at column B; maximum 6 batches retained.</a:t>
-            </a:r>
-          </a:p>
-        </p:txBody>
-      </p:sp>
-      <p:sp>
-        <p:nvSpPr>
-          <p:cNvPr id="27" name="Rectangle 26"/>
+          <p:cNvPr id="35" name="Rectangle 34"/>
           <p:cNvSpPr/>
           <p:nvPr/>
         </p:nvSpPr>
         <p:spPr>
           <a:xfrm>
-            <a:off x="5989320" y="5477256"/>
-            <a:ext cx="5833872" cy="859536"/>
-          </a:xfrm>
-          <a:prstGeom prst="rect">
-            <a:avLst/>
-          </a:prstGeom>
-          <a:solidFill>
-            <a:srgbClr val="F4F6FA"/>
-          </a:solidFill>
-          <a:ln w="6350">
-            <a:solidFill>
-              <a:srgbClr val="E0E4EE"/>
-            </a:solidFill>
+            <a:off x="594360" y="5870448"/>
+            <a:ext cx="329184" cy="329184"/>
+          </a:xfrm>
+          <a:prstGeom prst="rect">
+            <a:avLst/>
+          </a:prstGeom>
+          <a:solidFill>
+            <a:srgbClr val="1C3880"/>
+          </a:solidFill>
+          <a:ln>
+            <a:noFill/>
           </a:ln>
         </p:spPr>
         <p:style>
@@ -9865,57 +9862,14 @@
       </p:sp>
       <p:sp>
         <p:nvSpPr>
-          <p:cNvPr id="28" name="Rectangle 27"/>
-          <p:cNvSpPr/>
-          <p:nvPr/>
-        </p:nvSpPr>
-        <p:spPr>
-          <a:xfrm>
-            <a:off x="5989320" y="5477256"/>
-            <a:ext cx="45720" cy="859536"/>
-          </a:xfrm>
-          <a:prstGeom prst="rect">
-            <a:avLst/>
-          </a:prstGeom>
-          <a:solidFill>
-            <a:srgbClr val="F5A000"/>
-          </a:solidFill>
-          <a:ln>
-            <a:noFill/>
-          </a:ln>
-        </p:spPr>
-        <p:style>
-          <a:lnRef idx="1">
-            <a:schemeClr val="accent1"/>
-          </a:lnRef>
-          <a:fillRef idx="3">
-            <a:schemeClr val="accent1"/>
-          </a:fillRef>
-          <a:effectRef idx="2">
-            <a:schemeClr val="accent1"/>
-          </a:effectRef>
-          <a:fontRef idx="minor">
-            <a:schemeClr val="lt1"/>
-          </a:fontRef>
-        </p:style>
-        <p:txBody>
-          <a:bodyPr rtlCol="0" anchor="ctr"/>
-          <a:lstStyle/>
-          <a:p>
-            <a:pPr algn="ctr"/>
-          </a:p>
-        </p:txBody>
-      </p:sp>
-      <p:sp>
-        <p:nvSpPr>
-          <p:cNvPr id="29" name="TextBox 28"/>
+          <p:cNvPr id="36" name="TextBox 35"/>
           <p:cNvSpPr txBox="1"/>
           <p:nvPr/>
         </p:nvSpPr>
         <p:spPr>
           <a:xfrm>
-            <a:off x="6126480" y="5532120"/>
-            <a:ext cx="5650992" cy="320040"/>
+            <a:off x="594360" y="5861304"/>
+            <a:ext cx="329184" cy="329184"/>
           </a:xfrm>
           <a:prstGeom prst="rect">
             <a:avLst/>
@@ -9928,29 +9882,29 @@
           </a:bodyPr>
           <a:lstStyle/>
           <a:p>
-            <a:pPr algn="l"/>
-            <a:r>
-              <a:rPr sz="1100" b="1" i="0">
-                <a:solidFill>
-                  <a:srgbClr val="1C3880"/>
-                </a:solidFill>
-                <a:latin typeface="Consolas"/>
-              </a:rPr>
-              <a:t>scraper.log</a:t>
-            </a:r>
-          </a:p>
-        </p:txBody>
-      </p:sp>
-      <p:sp>
-        <p:nvSpPr>
-          <p:cNvPr id="30" name="TextBox 29"/>
+            <a:pPr algn="ctr"/>
+            <a:r>
+              <a:rPr sz="1200" b="1" i="0">
+                <a:solidFill>
+                  <a:srgbClr val="FFFFFF"/>
+                </a:solidFill>
+                <a:latin typeface="Segoe UI"/>
+              </a:rPr>
+              <a:t>5</a:t>
+            </a:r>
+          </a:p>
+        </p:txBody>
+      </p:sp>
+      <p:sp>
+        <p:nvSpPr>
+          <p:cNvPr id="37" name="TextBox 36"/>
           <p:cNvSpPr txBox="1"/>
           <p:nvPr/>
         </p:nvSpPr>
         <p:spPr>
           <a:xfrm>
-            <a:off x="6126480" y="5843016"/>
-            <a:ext cx="5650992" cy="457200"/>
+            <a:off x="1051560" y="5678424"/>
+            <a:ext cx="2194560" cy="320040"/>
           </a:xfrm>
           <a:prstGeom prst="rect">
             <a:avLst/>
@@ -9965,13 +9919,48 @@
           <a:p>
             <a:pPr algn="l"/>
             <a:r>
+              <a:rPr sz="1200" b="1" i="0">
+                <a:solidFill>
+                  <a:srgbClr val="1C3880"/>
+                </a:solidFill>
+                <a:latin typeface="Segoe UI"/>
+              </a:rPr>
+              <a:t>Clickable Source Links</a:t>
+            </a:r>
+          </a:p>
+        </p:txBody>
+      </p:sp>
+      <p:sp>
+        <p:nvSpPr>
+          <p:cNvPr id="38" name="TextBox 37"/>
+          <p:cNvSpPr txBox="1"/>
+          <p:nvPr/>
+        </p:nvSpPr>
+        <p:spPr>
+          <a:xfrm>
+            <a:off x="1051560" y="5989320"/>
+            <a:ext cx="10561320" cy="457200"/>
+          </a:xfrm>
+          <a:prstGeom prst="rect">
+            <a:avLst/>
+          </a:prstGeom>
+          <a:noFill/>
+        </p:spPr>
+        <p:txBody>
+          <a:bodyPr wrap="square">
+            <a:spAutoFit/>
+          </a:bodyPr>
+          <a:lstStyle/>
+          <a:p>
+            <a:pPr algn="l"/>
+            <a:r>
               <a:rPr sz="1050" b="0" i="0">
                 <a:solidFill>
                   <a:srgbClr val="333344"/>
                 </a:solidFill>
                 <a:latin typeface="Segoe UI"/>
               </a:rPr>
-              <a:t>Full structured log of every run — useful for diagnosing 0-tender results or network / ChromeDriver failures.</a:t>
+              <a:t>Every tender row contains a hyperlink directly to the official listing on etenders.gov.za — one click to access the full tender document and submission instructions.</a:t>
             </a:r>
           </a:p>
         </p:txBody>
@@ -10145,7 +10134,7 @@
                 </a:solidFill>
                 <a:latin typeface="Segoe UI"/>
               </a:rPr>
-              <a:t>23 fields extracted per tender</a:t>
+              <a:t>Every tender record contains up to 23 fields of structured information</a:t>
             </a:r>
           </a:p>
         </p:txBody>
@@ -10223,7 +10212,7 @@
                 </a:solidFill>
                 <a:latin typeface="Segoe UI"/>
               </a:rPr>
-              <a:t>Amidel (Pty) Ltd  |  Beyond Technology  |  eTender Scraper</a:t>
+              <a:t>Amidel (Pty) Ltd  |  Beyond Technology  |  Tender Intelligence</a:t>
             </a:r>
           </a:p>
         </p:txBody>
@@ -10334,9 +10323,9 @@
                 <a:solidFill>
                   <a:srgbClr val="FFFFFF"/>
                 </a:solidFill>
-                <a:latin typeface="Consolas"/>
-              </a:rPr>
-              <a:t>REPORT_DATE</a:t>
+                <a:latin typeface="Segoe UI"/>
+              </a:rPr>
+              <a:t>Report Date</a:t>
             </a:r>
           </a:p>
         </p:txBody>
@@ -10371,7 +10360,7 @@
                 </a:solidFill>
                 <a:latin typeface="Segoe UI"/>
               </a:rPr>
-              <a:t>Date the scraper was run</a:t>
+              <a:t>The reporting period this tender belongs to</a:t>
             </a:r>
           </a:p>
         </p:txBody>
@@ -10447,9 +10436,9 @@
                 <a:solidFill>
                   <a:srgbClr val="FFFFFF"/>
                 </a:solidFill>
-                <a:latin typeface="Consolas"/>
-              </a:rPr>
-              <a:t>RECORD_ID</a:t>
+                <a:latin typeface="Segoe UI"/>
+              </a:rPr>
+              <a:t>Tender ID</a:t>
             </a:r>
           </a:p>
         </p:txBody>
@@ -10484,7 +10473,7 @@
                 </a:solidFill>
                 <a:latin typeface="Segoe UI"/>
               </a:rPr>
-              <a:t>Auto-assigned ID (highest = first scraped)</a:t>
+              <a:t>Official government tender reference number</a:t>
             </a:r>
           </a:p>
         </p:txBody>
@@ -10560,9 +10549,9 @@
                 <a:solidFill>
                   <a:srgbClr val="FFFFFF"/>
                 </a:solidFill>
-                <a:latin typeface="Consolas"/>
-              </a:rPr>
-              <a:t>TENDER_ID</a:t>
+                <a:latin typeface="Segoe UI"/>
+              </a:rPr>
+              <a:t>Publication Date</a:t>
             </a:r>
           </a:p>
         </p:txBody>
@@ -10597,7 +10586,7 @@
                 </a:solidFill>
                 <a:latin typeface="Segoe UI"/>
               </a:rPr>
-              <a:t>Official tender number</a:t>
+              <a:t>When the tender was published on eTenders</a:t>
             </a:r>
           </a:p>
         </p:txBody>
@@ -10673,9 +10662,9 @@
                 <a:solidFill>
                   <a:srgbClr val="FFFFFF"/>
                 </a:solidFill>
-                <a:latin typeface="Consolas"/>
-              </a:rPr>
-              <a:t>PUBLICATION_DATE</a:t>
+                <a:latin typeface="Segoe UI"/>
+              </a:rPr>
+              <a:t>Closing Date &amp; Time</a:t>
             </a:r>
           </a:p>
         </p:txBody>
@@ -10710,7 +10699,7 @@
                 </a:solidFill>
                 <a:latin typeface="Segoe UI"/>
               </a:rPr>
-              <a:t>When the tender was published</a:t>
+              <a:t>Submission deadline — date and exact time</a:t>
             </a:r>
           </a:p>
         </p:txBody>
@@ -10786,9 +10775,9 @@
                 <a:solidFill>
                   <a:srgbClr val="FFFFFF"/>
                 </a:solidFill>
-                <a:latin typeface="Consolas"/>
-              </a:rPr>
-              <a:t>CLOSING_DATE / TIME</a:t>
+                <a:latin typeface="Segoe UI"/>
+              </a:rPr>
+              <a:t>Tender Type</a:t>
             </a:r>
           </a:p>
         </p:txBody>
@@ -10823,7 +10812,7 @@
                 </a:solidFill>
                 <a:latin typeface="Segoe UI"/>
               </a:rPr>
-              <a:t>Submission deadline</a:t>
+              <a:t>e.g. RFQ, Open Tender, Negotiation, etc.</a:t>
             </a:r>
           </a:p>
         </p:txBody>
@@ -10899,9 +10888,9 @@
                 <a:solidFill>
                   <a:srgbClr val="FFFFFF"/>
                 </a:solidFill>
-                <a:latin typeface="Consolas"/>
-              </a:rPr>
-              <a:t>TENDER_TYPE</a:t>
+                <a:latin typeface="Segoe UI"/>
+              </a:rPr>
+              <a:t>Tender Description</a:t>
             </a:r>
           </a:p>
         </p:txBody>
@@ -10936,7 +10925,7 @@
                 </a:solidFill>
                 <a:latin typeface="Segoe UI"/>
               </a:rPr>
-              <a:t>e.g. RFQ, Open Tender, etc.</a:t>
+              <a:t>Full title and description of the tender</a:t>
             </a:r>
           </a:p>
         </p:txBody>
@@ -11012,9 +11001,9 @@
                 <a:solidFill>
                   <a:srgbClr val="FFFFFF"/>
                 </a:solidFill>
-                <a:latin typeface="Consolas"/>
-              </a:rPr>
-              <a:t>TENDER_DESCRIPTION</a:t>
+                <a:latin typeface="Segoe UI"/>
+              </a:rPr>
+              <a:t>Department</a:t>
             </a:r>
           </a:p>
         </p:txBody>
@@ -11049,7 +11038,7 @@
                 </a:solidFill>
                 <a:latin typeface="Segoe UI"/>
               </a:rPr>
-              <a:t>Full tender title / description</a:t>
+              <a:t>Organ of state advertising the tender</a:t>
             </a:r>
           </a:p>
         </p:txBody>
@@ -11125,9 +11114,9 @@
                 <a:solidFill>
                   <a:srgbClr val="FFFFFF"/>
                 </a:solidFill>
-                <a:latin typeface="Consolas"/>
-              </a:rPr>
-              <a:t>TENDER_SOURCE</a:t>
+                <a:latin typeface="Segoe UI"/>
+              </a:rPr>
+              <a:t>Province</a:t>
             </a:r>
           </a:p>
         </p:txBody>
@@ -11162,7 +11151,7 @@
                 </a:solidFill>
                 <a:latin typeface="Segoe UI"/>
               </a:rPr>
-              <a:t>Always ETENDERS.GOV.ZA</a:t>
+              <a:t>Province the department falls under</a:t>
             </a:r>
           </a:p>
         </p:txBody>
@@ -11238,9 +11227,9 @@
                 <a:solidFill>
                   <a:srgbClr val="FFFFFF"/>
                 </a:solidFill>
-                <a:latin typeface="Consolas"/>
-              </a:rPr>
-              <a:t>DEPARTMENT</a:t>
+                <a:latin typeface="Segoe UI"/>
+              </a:rPr>
+              <a:t>Category</a:t>
             </a:r>
           </a:p>
         </p:txBody>
@@ -11275,7 +11264,7 @@
                 </a:solidFill>
                 <a:latin typeface="Segoe UI"/>
               </a:rPr>
-              <a:t>Organ of state advertising the tender</a:t>
+              <a:t>Sector category (e.g. ICT, Construction)</a:t>
             </a:r>
           </a:p>
         </p:txBody>
@@ -11351,9 +11340,9 @@
                 <a:solidFill>
                   <a:srgbClr val="FFFFFF"/>
                 </a:solidFill>
-                <a:latin typeface="Consolas"/>
-              </a:rPr>
-              <a:t>PROVINCE</a:t>
+                <a:latin typeface="Segoe UI"/>
+              </a:rPr>
+              <a:t>eSubmission</a:t>
             </a:r>
           </a:p>
         </p:txBody>
@@ -11388,7 +11377,7 @@
                 </a:solidFill>
                 <a:latin typeface="Segoe UI"/>
               </a:rPr>
-              <a:t>Province of the department</a:t>
+              <a:t>Whether electronic submission is available</a:t>
             </a:r>
           </a:p>
         </p:txBody>
@@ -11464,9 +11453,9 @@
                 <a:solidFill>
                   <a:srgbClr val="FFFFFF"/>
                 </a:solidFill>
-                <a:latin typeface="Consolas"/>
-              </a:rPr>
-              <a:t>ESUBMISSION</a:t>
+                <a:latin typeface="Segoe UI"/>
+              </a:rPr>
+              <a:t>Briefing Session</a:t>
             </a:r>
           </a:p>
         </p:txBody>
@@ -11501,7 +11490,7 @@
                 </a:solidFill>
                 <a:latin typeface="Segoe UI"/>
               </a:rPr>
-              <a:t>Whether e-submission is available</a:t>
+              <a:t>Whether a briefing session has been scheduled</a:t>
             </a:r>
           </a:p>
         </p:txBody>
@@ -11577,9 +11566,9 @@
                 <a:solidFill>
                   <a:srgbClr val="FFFFFF"/>
                 </a:solidFill>
-                <a:latin typeface="Consolas"/>
-              </a:rPr>
-              <a:t>CATEGORY</a:t>
+                <a:latin typeface="Segoe UI"/>
+              </a:rPr>
+              <a:t>Briefing Date</a:t>
             </a:r>
           </a:p>
         </p:txBody>
@@ -11614,7 +11603,7 @@
                 </a:solidFill>
                 <a:latin typeface="Segoe UI"/>
               </a:rPr>
-              <a:t>Tender category (e.g. ICT, Construction)</a:t>
+              <a:t>Date of the briefing session (Tender Summary only)</a:t>
             </a:r>
           </a:p>
         </p:txBody>
@@ -11690,9 +11679,9 @@
                 <a:solidFill>
                   <a:srgbClr val="FFFFFF"/>
                 </a:solidFill>
-                <a:latin typeface="Consolas"/>
-              </a:rPr>
-              <a:t>BRIEFING_DATE / VENUE</a:t>
+                <a:latin typeface="Segoe UI"/>
+              </a:rPr>
+              <a:t>Compulsory Briefing</a:t>
             </a:r>
           </a:p>
         </p:txBody>
@@ -11727,7 +11716,7 @@
                 </a:solidFill>
                 <a:latin typeface="Segoe UI"/>
               </a:rPr>
-              <a:t>Briefing session details if applicable</a:t>
+              <a:t>Whether attendance at briefing is mandatory</a:t>
             </a:r>
           </a:p>
         </p:txBody>
@@ -11803,9 +11792,9 @@
                 <a:solidFill>
                   <a:srgbClr val="FFFFFF"/>
                 </a:solidFill>
-                <a:latin typeface="Consolas"/>
-              </a:rPr>
-              <a:t>COMPULSORY_BRIEFING</a:t>
+                <a:latin typeface="Segoe UI"/>
+              </a:rPr>
+              <a:t>Briefing Venue</a:t>
             </a:r>
           </a:p>
         </p:txBody>
@@ -11840,7 +11829,7 @@
                 </a:solidFill>
                 <a:latin typeface="Segoe UI"/>
               </a:rPr>
-              <a:t>Whether attendance is mandatory</a:t>
+              <a:t>Location or details of the briefing session</a:t>
             </a:r>
           </a:p>
         </p:txBody>
@@ -11916,9 +11905,9 @@
                 <a:solidFill>
                   <a:srgbClr val="FFFFFF"/>
                 </a:solidFill>
-                <a:latin typeface="Consolas"/>
-              </a:rPr>
-              <a:t>LINK</a:t>
+                <a:latin typeface="Segoe UI"/>
+              </a:rPr>
+              <a:t>Link</a:t>
             </a:r>
           </a:p>
         </p:txBody>
@@ -11953,7 +11942,7 @@
                 </a:solidFill>
                 <a:latin typeface="Segoe UI"/>
               </a:rPr>
-              <a:t>Clickable hyperlink to tender document</a:t>
+              <a:t>Direct clickable link to the tender document</a:t>
             </a:r>
           </a:p>
         </p:txBody>
@@ -12029,9 +12018,9 @@
                 <a:solidFill>
                   <a:srgbClr val="FFFFFF"/>
                 </a:solidFill>
-                <a:latin typeface="Consolas"/>
-              </a:rPr>
-              <a:t>SOE</a:t>
+                <a:latin typeface="Segoe UI"/>
+              </a:rPr>
+              <a:t>SOE Flag</a:t>
             </a:r>
           </a:p>
         </p:txBody>
@@ -12066,7 +12055,7 @@
                 </a:solidFill>
                 <a:latin typeface="Segoe UI"/>
               </a:rPr>
-              <a:t>State-owned enterprise flag</a:t>
+              <a:t>Whether the entity is a state-owned enterprise</a:t>
             </a:r>
           </a:p>
         </p:txBody>
@@ -12142,9 +12131,9 @@
                 <a:solidFill>
                   <a:srgbClr val="FFFFFF"/>
                 </a:solidFill>
-                <a:latin typeface="Consolas"/>
-              </a:rPr>
-              <a:t>COST_OF_SALES_ESTIMATE</a:t>
+                <a:latin typeface="Segoe UI"/>
+              </a:rPr>
+              <a:t>Cost of Sales Estimate</a:t>
             </a:r>
           </a:p>
         </p:txBody>
@@ -12179,7 +12168,7 @@
                 </a:solidFill>
                 <a:latin typeface="Segoe UI"/>
               </a:rPr>
-              <a:t>Estimated cost / value</a:t>
+              <a:t>Estimated value or cost attached to the tender</a:t>
             </a:r>
           </a:p>
         </p:txBody>
@@ -12255,9 +12244,9 @@
                 <a:solidFill>
                   <a:srgbClr val="FFFFFF"/>
                 </a:solidFill>
-                <a:latin typeface="Consolas"/>
-              </a:rPr>
-              <a:t>CAPABILITY_AVAILABLE/GROUP</a:t>
+                <a:latin typeface="Segoe UI"/>
+              </a:rPr>
+              <a:t>Capability Available</a:t>
             </a:r>
           </a:p>
         </p:txBody>
@@ -12292,7 +12281,7 @@
                 </a:solidFill>
                 <a:latin typeface="Segoe UI"/>
               </a:rPr>
-              <a:t>Capability classification</a:t>
+              <a:t>Internal capability classification</a:t>
             </a:r>
           </a:p>
         </p:txBody>
@@ -12368,9 +12357,9 @@
                 <a:solidFill>
                   <a:srgbClr val="FFFFFF"/>
                 </a:solidFill>
-                <a:latin typeface="Consolas"/>
-              </a:rPr>
-              <a:t>REQUIREMENTS</a:t>
+                <a:latin typeface="Segoe UI"/>
+              </a:rPr>
+              <a:t>Requirements</a:t>
             </a:r>
           </a:p>
         </p:txBody>
@@ -12405,7 +12394,7 @@
                 </a:solidFill>
                 <a:latin typeface="Segoe UI"/>
               </a:rPr>
-              <a:t>Any special requirements listed</a:t>
+              <a:t>Any special requirements listed on the tender</a:t>
             </a:r>
           </a:p>
         </p:txBody>
@@ -12544,7 +12533,7 @@
                 </a:solidFill>
                 <a:latin typeface="Segoe UI"/>
               </a:rPr>
-              <a:t>Tracked Departments</a:t>
+              <a:t>Coverage</a:t>
             </a:r>
           </a:p>
         </p:txBody>
@@ -12579,7 +12568,7 @@
                 </a:solidFill>
                 <a:latin typeface="Segoe UI"/>
               </a:rPr>
-              <a:t>25 organs of state monitored each batch</a:t>
+              <a:t>26 organs of state monitored every reporting period</a:t>
             </a:r>
           </a:p>
         </p:txBody>
@@ -12657,7 +12646,7 @@
                 </a:solidFill>
                 <a:latin typeface="Segoe UI"/>
               </a:rPr>
-              <a:t>Amidel (Pty) Ltd  |  Beyond Technology  |  eTender Scraper</a:t>
+              <a:t>Amidel (Pty) Ltd  |  Beyond Technology  |  Tender Intelligence</a:t>
             </a:r>
           </a:p>
         </p:txBody>
@@ -12727,7 +12716,7 @@
                 </a:solidFill>
                 <a:latin typeface="Segoe UI"/>
               </a:rPr>
-              <a:t>For each batch the Final tab and Tender Summary produce counts of NNT, ICT, and RFQ tenders broken down by the following departments. New departments can be added by editing BatchProcessor.py.</a:t>
+              <a:t>The following departments and organs of state are tracked each batch. For each one, the reports show the number of new tenders (NNT), ICT tenders, and RFQs. The list can be customised to match your pipeline.</a:t>
             </a:r>
           </a:p>
         </p:txBody>
@@ -15759,7 +15748,130 @@
                 </a:solidFill>
                 <a:latin typeface="Segoe UI"/>
               </a:rPr>
-              <a:t>CP JHB / W JHB</a:t>
+              <a:t>CP JHB</a:t>
+            </a:r>
+          </a:p>
+        </p:txBody>
+      </p:sp>
+      <p:sp>
+        <p:nvSpPr>
+          <p:cNvPr id="84" name="Rectangle 83"/>
+          <p:cNvSpPr/>
+          <p:nvPr/>
+        </p:nvSpPr>
+        <p:spPr>
+          <a:xfrm>
+            <a:off x="457200" y="4800600"/>
+            <a:ext cx="2240280" cy="384048"/>
+          </a:xfrm>
+          <a:prstGeom prst="rect">
+            <a:avLst/>
+          </a:prstGeom>
+          <a:solidFill>
+            <a:srgbClr val="F4F6FA"/>
+          </a:solidFill>
+          <a:ln w="7620">
+            <a:solidFill>
+              <a:srgbClr val="254499"/>
+            </a:solidFill>
+          </a:ln>
+        </p:spPr>
+        <p:style>
+          <a:lnRef idx="1">
+            <a:schemeClr val="accent1"/>
+          </a:lnRef>
+          <a:fillRef idx="3">
+            <a:schemeClr val="accent1"/>
+          </a:fillRef>
+          <a:effectRef idx="2">
+            <a:schemeClr val="accent1"/>
+          </a:effectRef>
+          <a:fontRef idx="minor">
+            <a:schemeClr val="lt1"/>
+          </a:fontRef>
+        </p:style>
+        <p:txBody>
+          <a:bodyPr rtlCol="0" anchor="ctr"/>
+          <a:lstStyle/>
+          <a:p>
+            <a:pPr algn="ctr"/>
+          </a:p>
+        </p:txBody>
+      </p:sp>
+      <p:sp>
+        <p:nvSpPr>
+          <p:cNvPr id="85" name="Rectangle 84"/>
+          <p:cNvSpPr/>
+          <p:nvPr/>
+        </p:nvSpPr>
+        <p:spPr>
+          <a:xfrm>
+            <a:off x="457200" y="4800600"/>
+            <a:ext cx="36576" cy="384048"/>
+          </a:xfrm>
+          <a:prstGeom prst="rect">
+            <a:avLst/>
+          </a:prstGeom>
+          <a:solidFill>
+            <a:srgbClr val="F5A000"/>
+          </a:solidFill>
+          <a:ln>
+            <a:noFill/>
+          </a:ln>
+        </p:spPr>
+        <p:style>
+          <a:lnRef idx="1">
+            <a:schemeClr val="accent1"/>
+          </a:lnRef>
+          <a:fillRef idx="3">
+            <a:schemeClr val="accent1"/>
+          </a:fillRef>
+          <a:effectRef idx="2">
+            <a:schemeClr val="accent1"/>
+          </a:effectRef>
+          <a:fontRef idx="minor">
+            <a:schemeClr val="lt1"/>
+          </a:fontRef>
+        </p:style>
+        <p:txBody>
+          <a:bodyPr rtlCol="0" anchor="ctr"/>
+          <a:lstStyle/>
+          <a:p>
+            <a:pPr algn="ctr"/>
+          </a:p>
+        </p:txBody>
+      </p:sp>
+      <p:sp>
+        <p:nvSpPr>
+          <p:cNvPr id="86" name="TextBox 85"/>
+          <p:cNvSpPr txBox="1"/>
+          <p:nvPr/>
+        </p:nvSpPr>
+        <p:spPr>
+          <a:xfrm>
+            <a:off x="530352" y="4864608"/>
+            <a:ext cx="2167128" cy="310896"/>
+          </a:xfrm>
+          <a:prstGeom prst="rect">
+            <a:avLst/>
+          </a:prstGeom>
+          <a:noFill/>
+        </p:spPr>
+        <p:txBody>
+          <a:bodyPr wrap="square">
+            <a:spAutoFit/>
+          </a:bodyPr>
+          <a:lstStyle/>
+          <a:p>
+            <a:pPr algn="l"/>
+            <a:r>
+              <a:rPr sz="1100" b="0" i="0">
+                <a:solidFill>
+                  <a:srgbClr val="1C3880"/>
+                </a:solidFill>
+                <a:latin typeface="Segoe UI"/>
+              </a:rPr>
+              <a:t>W JHB</a:t>
             </a:r>
           </a:p>
         </p:txBody>
@@ -15898,7 +16010,7 @@
                 </a:solidFill>
                 <a:latin typeface="Segoe UI"/>
               </a:rPr>
-              <a:t>Technical Stack</a:t>
+              <a:t>Why Amidel</a:t>
             </a:r>
           </a:p>
         </p:txBody>
@@ -15933,7 +16045,7 @@
                 </a:solidFill>
                 <a:latin typeface="Segoe UI"/>
               </a:rPr>
-              <a:t>Built on proven, open-source Python libraries</a:t>
+              <a:t>Local expertise. Custom solutions. Real results.</a:t>
             </a:r>
           </a:p>
         </p:txBody>
@@ -16011,7 +16123,7 @@
                 </a:solidFill>
                 <a:latin typeface="Segoe UI"/>
               </a:rPr>
-              <a:t>Amidel (Pty) Ltd  |  Beyond Technology  |  eTender Scraper</a:t>
+              <a:t>Amidel (Pty) Ltd  |  Beyond Technology  |  Tender Intelligence</a:t>
             </a:r>
           </a:p>
         </p:txBody>
@@ -16059,8 +16171,8 @@
         </p:nvSpPr>
         <p:spPr>
           <a:xfrm>
-            <a:off x="384048" y="1508760"/>
-            <a:ext cx="3520440" cy="2011680"/>
+            <a:off x="411480" y="1508760"/>
+            <a:ext cx="5394960" cy="1508760"/>
           </a:xfrm>
           <a:prstGeom prst="rect">
             <a:avLst/>
@@ -16104,8 +16216,8 @@
         </p:nvSpPr>
         <p:spPr>
           <a:xfrm>
-            <a:off x="384048" y="1508760"/>
-            <a:ext cx="54864" cy="2011680"/>
+            <a:off x="411480" y="1508760"/>
+            <a:ext cx="50292" cy="1508760"/>
           </a:xfrm>
           <a:prstGeom prst="rect">
             <a:avLst/>
@@ -16147,8 +16259,8 @@
         </p:nvSpPr>
         <p:spPr>
           <a:xfrm>
-            <a:off x="548640" y="1636776"/>
-            <a:ext cx="3291840" cy="411480"/>
+            <a:off x="576072" y="1636776"/>
+            <a:ext cx="5193792" cy="1380744"/>
           </a:xfrm>
           <a:prstGeom prst="rect">
             <a:avLst/>
@@ -16163,73 +16275,15 @@
           <a:p>
             <a:pPr algn="l"/>
             <a:r>
-              <a:rPr sz="1700" b="1" i="0">
+              <a:rPr sz="1400" b="1">
                 <a:solidFill>
                   <a:srgbClr val="1C3880"/>
                 </a:solidFill>
                 <a:latin typeface="Segoe UI"/>
               </a:rPr>
-              <a:t>Python 3</a:t>
-            </a:r>
-          </a:p>
-        </p:txBody>
-      </p:sp>
-      <p:sp>
-        <p:nvSpPr>
-          <p:cNvPr id="12" name="TextBox 11"/>
-          <p:cNvSpPr txBox="1"/>
-          <p:nvPr/>
-        </p:nvSpPr>
-        <p:spPr>
-          <a:xfrm>
-            <a:off x="548640" y="2039112"/>
-            <a:ext cx="3291840" cy="274320"/>
-          </a:xfrm>
-          <a:prstGeom prst="rect">
-            <a:avLst/>
-          </a:prstGeom>
-          <a:noFill/>
-        </p:spPr>
-        <p:txBody>
-          <a:bodyPr wrap="square">
-            <a:spAutoFit/>
-          </a:bodyPr>
-          <a:lstStyle/>
-          <a:p>
-            <a:pPr algn="l"/>
-            <a:r>
-              <a:rPr sz="1100" b="1" i="1">
-                <a:solidFill>
-                  <a:srgbClr val="F5A000"/>
-                </a:solidFill>
-                <a:latin typeface="Segoe UI"/>
-              </a:rPr>
-              <a:t>Core language</a:t>
-            </a:r>
-          </a:p>
-        </p:txBody>
-      </p:sp>
-      <p:sp>
-        <p:nvSpPr>
-          <p:cNvPr id="13" name="TextBox 12"/>
-          <p:cNvSpPr txBox="1"/>
-          <p:nvPr/>
-        </p:nvSpPr>
-        <p:spPr>
-          <a:xfrm>
-            <a:off x="548640" y="2331720"/>
-            <a:ext cx="3291840" cy="1005840"/>
-          </a:xfrm>
-          <a:prstGeom prst="rect">
-            <a:avLst/>
-          </a:prstGeom>
-          <a:noFill/>
-        </p:spPr>
-        <p:txBody>
-          <a:bodyPr wrap="square">
-            <a:spAutoFit/>
-          </a:bodyPr>
-          <a:lstStyle/>
+              <a:t>Built for South Africa</a:t>
+            </a:r>
+          </a:p>
           <a:p>
             <a:pPr algn="l"/>
             <a:r>
@@ -16239,21 +16293,57 @@
                 </a:solidFill>
                 <a:latin typeface="Segoe UI"/>
               </a:rPr>
-              <a:t>Clean, maintainable codebase with no compiled dependencies.</a:t>
-            </a:r>
-          </a:p>
-        </p:txBody>
-      </p:sp>
-      <p:sp>
-        <p:nvSpPr>
-          <p:cNvPr id="14" name="Rectangle 13"/>
+              <a:t>• Designed specifically for etenders.gov.za</a:t>
+            </a:r>
+          </a:p>
+          <a:p>
+            <a:pPr algn="l"/>
+            <a:r>
+              <a:rPr sz="1200" b="0" i="0">
+                <a:solidFill>
+                  <a:srgbClr val="333344"/>
+                </a:solidFill>
+                <a:latin typeface="Segoe UI"/>
+              </a:rPr>
+              <a:t>• Understands the SA government procurement landscape</a:t>
+            </a:r>
+          </a:p>
+          <a:p>
+            <a:pPr algn="l"/>
+            <a:r>
+              <a:rPr sz="1200" b="0" i="0">
+                <a:solidFill>
+                  <a:srgbClr val="333344"/>
+                </a:solidFill>
+                <a:latin typeface="Segoe UI"/>
+              </a:rPr>
+              <a:t>• Tracks the organs of state relevant to your sector</a:t>
+            </a:r>
+          </a:p>
+          <a:p>
+            <a:pPr algn="l"/>
+            <a:r>
+              <a:rPr sz="1200" b="0" i="0">
+                <a:solidFill>
+                  <a:srgbClr val="333344"/>
+                </a:solidFill>
+                <a:latin typeface="Segoe UI"/>
+              </a:rPr>
+              <a:t>• Adapts to local tender formats and classifications</a:t>
+            </a:r>
+          </a:p>
+        </p:txBody>
+      </p:sp>
+      <p:sp>
+        <p:nvSpPr>
+          <p:cNvPr id="12" name="Rectangle 11"/>
           <p:cNvSpPr/>
           <p:nvPr/>
         </p:nvSpPr>
         <p:spPr>
           <a:xfrm>
-            <a:off x="4178808" y="1508760"/>
-            <a:ext cx="3520440" cy="2011680"/>
+            <a:off x="6309360" y="1508760"/>
+            <a:ext cx="5394960" cy="1508760"/>
           </a:xfrm>
           <a:prstGeom prst="rect">
             <a:avLst/>
@@ -16291,14 +16381,14 @@
       </p:sp>
       <p:sp>
         <p:nvSpPr>
-          <p:cNvPr id="15" name="Rectangle 14"/>
+          <p:cNvPr id="13" name="Rectangle 12"/>
           <p:cNvSpPr/>
           <p:nvPr/>
         </p:nvSpPr>
         <p:spPr>
           <a:xfrm>
-            <a:off x="4178808" y="1508760"/>
-            <a:ext cx="54864" cy="2011680"/>
+            <a:off x="6309360" y="1508760"/>
+            <a:ext cx="50292" cy="1508760"/>
           </a:xfrm>
           <a:prstGeom prst="rect">
             <a:avLst/>
@@ -16334,14 +16424,14 @@
       </p:sp>
       <p:sp>
         <p:nvSpPr>
-          <p:cNvPr id="16" name="TextBox 15"/>
+          <p:cNvPr id="14" name="TextBox 13"/>
           <p:cNvSpPr txBox="1"/>
           <p:nvPr/>
         </p:nvSpPr>
         <p:spPr>
           <a:xfrm>
-            <a:off x="4343400" y="1636776"/>
-            <a:ext cx="3291840" cy="411480"/>
+            <a:off x="6473952" y="1636776"/>
+            <a:ext cx="5193792" cy="1380744"/>
           </a:xfrm>
           <a:prstGeom prst="rect">
             <a:avLst/>
@@ -16356,73 +16446,15 @@
           <a:p>
             <a:pPr algn="l"/>
             <a:r>
-              <a:rPr sz="1700" b="1" i="0">
+              <a:rPr sz="1400" b="1">
                 <a:solidFill>
                   <a:srgbClr val="1C3880"/>
                 </a:solidFill>
                 <a:latin typeface="Segoe UI"/>
               </a:rPr>
-              <a:t>Tkinter + tkcalendar</a:t>
-            </a:r>
-          </a:p>
-        </p:txBody>
-      </p:sp>
-      <p:sp>
-        <p:nvSpPr>
-          <p:cNvPr id="17" name="TextBox 16"/>
-          <p:cNvSpPr txBox="1"/>
-          <p:nvPr/>
-        </p:nvSpPr>
-        <p:spPr>
-          <a:xfrm>
-            <a:off x="4343400" y="2039112"/>
-            <a:ext cx="3291840" cy="274320"/>
-          </a:xfrm>
-          <a:prstGeom prst="rect">
-            <a:avLst/>
-          </a:prstGeom>
-          <a:noFill/>
-        </p:spPr>
-        <p:txBody>
-          <a:bodyPr wrap="square">
-            <a:spAutoFit/>
-          </a:bodyPr>
-          <a:lstStyle/>
-          <a:p>
-            <a:pPr algn="l"/>
-            <a:r>
-              <a:rPr sz="1100" b="1" i="1">
-                <a:solidFill>
-                  <a:srgbClr val="F5A000"/>
-                </a:solidFill>
-                <a:latin typeface="Segoe UI"/>
-              </a:rPr>
-              <a:t>GUI framework</a:t>
-            </a:r>
-          </a:p>
-        </p:txBody>
-      </p:sp>
-      <p:sp>
-        <p:nvSpPr>
-          <p:cNvPr id="18" name="TextBox 17"/>
-          <p:cNvSpPr txBox="1"/>
-          <p:nvPr/>
-        </p:nvSpPr>
-        <p:spPr>
-          <a:xfrm>
-            <a:off x="4343400" y="2331720"/>
-            <a:ext cx="3291840" cy="1005840"/>
-          </a:xfrm>
-          <a:prstGeom prst="rect">
-            <a:avLst/>
-          </a:prstGeom>
-          <a:noFill/>
-        </p:spPr>
-        <p:txBody>
-          <a:bodyPr wrap="square">
-            <a:spAutoFit/>
-          </a:bodyPr>
-          <a:lstStyle/>
+              <a:t>Delivered, Not Just Built</a:t>
+            </a:r>
+          </a:p>
           <a:p>
             <a:pPr algn="l"/>
             <a:r>
@@ -16432,21 +16464,57 @@
                 </a:solidFill>
                 <a:latin typeface="Segoe UI"/>
               </a:rPr>
-              <a:t>Native desktop window with branded colours, calendar popup, and live log panel.</a:t>
-            </a:r>
-          </a:p>
-        </p:txBody>
-      </p:sp>
-      <p:sp>
-        <p:nvSpPr>
-          <p:cNvPr id="19" name="Rectangle 18"/>
+              <a:t>• Reports are generated and distributed automatically</a:t>
+            </a:r>
+          </a:p>
+          <a:p>
+            <a:pPr algn="l"/>
+            <a:r>
+              <a:rPr sz="1200" b="0" i="0">
+                <a:solidFill>
+                  <a:srgbClr val="333344"/>
+                </a:solidFill>
+                <a:latin typeface="Segoe UI"/>
+              </a:rPr>
+              <a:t>• Your team receives structured outputs — no setup required</a:t>
+            </a:r>
+          </a:p>
+          <a:p>
+            <a:pPr algn="l"/>
+            <a:r>
+              <a:rPr sz="1200" b="0" i="0">
+                <a:solidFill>
+                  <a:srgbClr val="333344"/>
+                </a:solidFill>
+                <a:latin typeface="Segoe UI"/>
+              </a:rPr>
+              <a:t>• OneDrive integration keeps everyone in sync</a:t>
+            </a:r>
+          </a:p>
+          <a:p>
+            <a:pPr algn="l"/>
+            <a:r>
+              <a:rPr sz="1200" b="0" i="0">
+                <a:solidFill>
+                  <a:srgbClr val="333344"/>
+                </a:solidFill>
+                <a:latin typeface="Segoe UI"/>
+              </a:rPr>
+              <a:t>• Consistent format every batch, without fail</a:t>
+            </a:r>
+          </a:p>
+        </p:txBody>
+      </p:sp>
+      <p:sp>
+        <p:nvSpPr>
+          <p:cNvPr id="15" name="Rectangle 14"/>
           <p:cNvSpPr/>
           <p:nvPr/>
         </p:nvSpPr>
         <p:spPr>
           <a:xfrm>
-            <a:off x="7973568" y="1508760"/>
-            <a:ext cx="3520440" cy="2011680"/>
+            <a:off x="411480" y="3154680"/>
+            <a:ext cx="5394960" cy="1508760"/>
           </a:xfrm>
           <a:prstGeom prst="rect">
             <a:avLst/>
@@ -16484,14 +16552,14 @@
       </p:sp>
       <p:sp>
         <p:nvSpPr>
-          <p:cNvPr id="20" name="Rectangle 19"/>
+          <p:cNvPr id="16" name="Rectangle 15"/>
           <p:cNvSpPr/>
           <p:nvPr/>
         </p:nvSpPr>
         <p:spPr>
           <a:xfrm>
-            <a:off x="7973568" y="1508760"/>
-            <a:ext cx="54864" cy="2011680"/>
+            <a:off x="411480" y="3154680"/>
+            <a:ext cx="50292" cy="1508760"/>
           </a:xfrm>
           <a:prstGeom prst="rect">
             <a:avLst/>
@@ -16527,14 +16595,14 @@
       </p:sp>
       <p:sp>
         <p:nvSpPr>
-          <p:cNvPr id="21" name="TextBox 20"/>
+          <p:cNvPr id="17" name="TextBox 16"/>
           <p:cNvSpPr txBox="1"/>
           <p:nvPr/>
         </p:nvSpPr>
         <p:spPr>
           <a:xfrm>
-            <a:off x="8138160" y="1636776"/>
-            <a:ext cx="3291840" cy="411480"/>
+            <a:off x="576072" y="3282696"/>
+            <a:ext cx="5193792" cy="1380744"/>
           </a:xfrm>
           <a:prstGeom prst="rect">
             <a:avLst/>
@@ -16549,73 +16617,15 @@
           <a:p>
             <a:pPr algn="l"/>
             <a:r>
-              <a:rPr sz="1700" b="1" i="0">
+              <a:rPr sz="1400" b="1">
                 <a:solidFill>
                   <a:srgbClr val="1C3880"/>
                 </a:solidFill>
                 <a:latin typeface="Segoe UI"/>
               </a:rPr>
-              <a:t>Selenium + ChromeDriver</a:t>
-            </a:r>
-          </a:p>
-        </p:txBody>
-      </p:sp>
-      <p:sp>
-        <p:nvSpPr>
-          <p:cNvPr id="22" name="TextBox 21"/>
-          <p:cNvSpPr txBox="1"/>
-          <p:nvPr/>
-        </p:nvSpPr>
-        <p:spPr>
-          <a:xfrm>
-            <a:off x="8138160" y="2039112"/>
-            <a:ext cx="3291840" cy="274320"/>
-          </a:xfrm>
-          <a:prstGeom prst="rect">
-            <a:avLst/>
-          </a:prstGeom>
-          <a:noFill/>
-        </p:spPr>
-        <p:txBody>
-          <a:bodyPr wrap="square">
-            <a:spAutoFit/>
-          </a:bodyPr>
-          <a:lstStyle/>
-          <a:p>
-            <a:pPr algn="l"/>
-            <a:r>
-              <a:rPr sz="1100" b="1" i="1">
-                <a:solidFill>
-                  <a:srgbClr val="F5A000"/>
-                </a:solidFill>
-                <a:latin typeface="Segoe UI"/>
-              </a:rPr>
-              <a:t>Web automation</a:t>
-            </a:r>
-          </a:p>
-        </p:txBody>
-      </p:sp>
-      <p:sp>
-        <p:nvSpPr>
-          <p:cNvPr id="23" name="TextBox 22"/>
-          <p:cNvSpPr txBox="1"/>
-          <p:nvPr/>
-        </p:nvSpPr>
-        <p:spPr>
-          <a:xfrm>
-            <a:off x="8138160" y="2331720"/>
-            <a:ext cx="3291840" cy="1005840"/>
-          </a:xfrm>
-          <a:prstGeom prst="rect">
-            <a:avLst/>
-          </a:prstGeom>
-          <a:noFill/>
-        </p:spPr>
-        <p:txBody>
-          <a:bodyPr wrap="square">
-            <a:spAutoFit/>
-          </a:bodyPr>
-          <a:lstStyle/>
+              <a:t>Customisable to Your Needs</a:t>
+            </a:r>
+          </a:p>
           <a:p>
             <a:pPr algn="l"/>
             <a:r>
@@ -16625,21 +16635,57 @@
                 </a:solidFill>
                 <a:latin typeface="Segoe UI"/>
               </a:rPr>
-              <a:t>Drives Chrome headlessly or visibly. Automatically manages ChromeDriver version.</a:t>
-            </a:r>
-          </a:p>
-        </p:txBody>
-      </p:sp>
-      <p:sp>
-        <p:nvSpPr>
-          <p:cNvPr id="24" name="Rectangle 23"/>
+              <a:t>• Department watchlist tailored to your pipeline</a:t>
+            </a:r>
+          </a:p>
+          <a:p>
+            <a:pPr algn="l"/>
+            <a:r>
+              <a:rPr sz="1200" b="0" i="0">
+                <a:solidFill>
+                  <a:srgbClr val="333344"/>
+                </a:solidFill>
+                <a:latin typeface="Segoe UI"/>
+              </a:rPr>
+              <a:t>• Additional classification fields can be added</a:t>
+            </a:r>
+          </a:p>
+          <a:p>
+            <a:pPr algn="l"/>
+            <a:r>
+              <a:rPr sz="1200" b="0" i="0">
+                <a:solidFill>
+                  <a:srgbClr val="333344"/>
+                </a:solidFill>
+                <a:latin typeface="Segoe UI"/>
+              </a:rPr>
+              <a:t>• Reporting cadence matches your business rhythm</a:t>
+            </a:r>
+          </a:p>
+          <a:p>
+            <a:pPr algn="l"/>
+            <a:r>
+              <a:rPr sz="1200" b="0" i="0">
+                <a:solidFill>
+                  <a:srgbClr val="333344"/>
+                </a:solidFill>
+                <a:latin typeface="Segoe UI"/>
+              </a:rPr>
+              <a:t>• Future modules: email delivery, dashboard views</a:t>
+            </a:r>
+          </a:p>
+        </p:txBody>
+      </p:sp>
+      <p:sp>
+        <p:nvSpPr>
+          <p:cNvPr id="18" name="Rectangle 17"/>
           <p:cNvSpPr/>
           <p:nvPr/>
         </p:nvSpPr>
         <p:spPr>
           <a:xfrm>
-            <a:off x="384048" y="3703320"/>
-            <a:ext cx="3520440" cy="2011680"/>
+            <a:off x="6309360" y="3154680"/>
+            <a:ext cx="5394960" cy="1508760"/>
           </a:xfrm>
           <a:prstGeom prst="rect">
             <a:avLst/>
@@ -16677,14 +16723,14 @@
       </p:sp>
       <p:sp>
         <p:nvSpPr>
-          <p:cNvPr id="25" name="Rectangle 24"/>
+          <p:cNvPr id="19" name="Rectangle 18"/>
           <p:cNvSpPr/>
           <p:nvPr/>
         </p:nvSpPr>
         <p:spPr>
           <a:xfrm>
-            <a:off x="384048" y="3703320"/>
-            <a:ext cx="54864" cy="2011680"/>
+            <a:off x="6309360" y="3154680"/>
+            <a:ext cx="50292" cy="1508760"/>
           </a:xfrm>
           <a:prstGeom prst="rect">
             <a:avLst/>
@@ -16720,14 +16766,14 @@
       </p:sp>
       <p:sp>
         <p:nvSpPr>
-          <p:cNvPr id="26" name="TextBox 25"/>
+          <p:cNvPr id="20" name="TextBox 19"/>
           <p:cNvSpPr txBox="1"/>
           <p:nvPr/>
         </p:nvSpPr>
         <p:spPr>
           <a:xfrm>
-            <a:off x="548640" y="3831336"/>
-            <a:ext cx="3291840" cy="411480"/>
+            <a:off x="6473952" y="3282696"/>
+            <a:ext cx="5193792" cy="1380744"/>
           </a:xfrm>
           <a:prstGeom prst="rect">
             <a:avLst/>
@@ -16742,73 +16788,15 @@
           <a:p>
             <a:pPr algn="l"/>
             <a:r>
-              <a:rPr sz="1700" b="1" i="0">
+              <a:rPr sz="1400" b="1">
                 <a:solidFill>
                   <a:srgbClr val="1C3880"/>
                 </a:solidFill>
                 <a:latin typeface="Segoe UI"/>
               </a:rPr>
-              <a:t>pandas</a:t>
-            </a:r>
-          </a:p>
-        </p:txBody>
-      </p:sp>
-      <p:sp>
-        <p:nvSpPr>
-          <p:cNvPr id="27" name="TextBox 26"/>
-          <p:cNvSpPr txBox="1"/>
-          <p:nvPr/>
-        </p:nvSpPr>
-        <p:spPr>
-          <a:xfrm>
-            <a:off x="548640" y="4233672"/>
-            <a:ext cx="3291840" cy="274320"/>
-          </a:xfrm>
-          <a:prstGeom prst="rect">
-            <a:avLst/>
-          </a:prstGeom>
-          <a:noFill/>
-        </p:spPr>
-        <p:txBody>
-          <a:bodyPr wrap="square">
-            <a:spAutoFit/>
-          </a:bodyPr>
-          <a:lstStyle/>
-          <a:p>
-            <a:pPr algn="l"/>
-            <a:r>
-              <a:rPr sz="1100" b="1" i="1">
-                <a:solidFill>
-                  <a:srgbClr val="F5A000"/>
-                </a:solidFill>
-                <a:latin typeface="Segoe UI"/>
-              </a:rPr>
-              <a:t>Data processing</a:t>
-            </a:r>
-          </a:p>
-        </p:txBody>
-      </p:sp>
-      <p:sp>
-        <p:nvSpPr>
-          <p:cNvPr id="28" name="TextBox 27"/>
-          <p:cNvSpPr txBox="1"/>
-          <p:nvPr/>
-        </p:nvSpPr>
-        <p:spPr>
-          <a:xfrm>
-            <a:off x="548640" y="4526280"/>
-            <a:ext cx="3291840" cy="1005840"/>
-          </a:xfrm>
-          <a:prstGeom prst="rect">
-            <a:avLst/>
-          </a:prstGeom>
-          <a:noFill/>
-        </p:spPr>
-        <p:txBody>
-          <a:bodyPr wrap="square">
-            <a:spAutoFit/>
-          </a:bodyPr>
-          <a:lstStyle/>
+              <a:t>Proven &amp; Actively Maintained</a:t>
+            </a:r>
+          </a:p>
           <a:p>
             <a:pPr algn="l"/>
             <a:r>
@@ -16818,190 +16806,9 @@
                 </a:solidFill>
                 <a:latin typeface="Segoe UI"/>
               </a:rPr>
-              <a:t>DataFrame operations for deduplication, merging, and column transformations.</a:t>
-            </a:r>
-          </a:p>
-        </p:txBody>
-      </p:sp>
-      <p:sp>
-        <p:nvSpPr>
-          <p:cNvPr id="29" name="Rectangle 28"/>
-          <p:cNvSpPr/>
-          <p:nvPr/>
-        </p:nvSpPr>
-        <p:spPr>
-          <a:xfrm>
-            <a:off x="4178808" y="3703320"/>
-            <a:ext cx="3520440" cy="2011680"/>
-          </a:xfrm>
-          <a:prstGeom prst="rect">
-            <a:avLst/>
-          </a:prstGeom>
-          <a:solidFill>
-            <a:srgbClr val="F4F6FA"/>
-          </a:solidFill>
-          <a:ln w="9525">
-            <a:solidFill>
-              <a:srgbClr val="E0E4EE"/>
-            </a:solidFill>
-          </a:ln>
-        </p:spPr>
-        <p:style>
-          <a:lnRef idx="1">
-            <a:schemeClr val="accent1"/>
-          </a:lnRef>
-          <a:fillRef idx="3">
-            <a:schemeClr val="accent1"/>
-          </a:fillRef>
-          <a:effectRef idx="2">
-            <a:schemeClr val="accent1"/>
-          </a:effectRef>
-          <a:fontRef idx="minor">
-            <a:schemeClr val="lt1"/>
-          </a:fontRef>
-        </p:style>
-        <p:txBody>
-          <a:bodyPr rtlCol="0" anchor="ctr"/>
-          <a:lstStyle/>
-          <a:p>
-            <a:pPr algn="ctr"/>
-          </a:p>
-        </p:txBody>
-      </p:sp>
-      <p:sp>
-        <p:nvSpPr>
-          <p:cNvPr id="30" name="Rectangle 29"/>
-          <p:cNvSpPr/>
-          <p:nvPr/>
-        </p:nvSpPr>
-        <p:spPr>
-          <a:xfrm>
-            <a:off x="4178808" y="3703320"/>
-            <a:ext cx="54864" cy="2011680"/>
-          </a:xfrm>
-          <a:prstGeom prst="rect">
-            <a:avLst/>
-          </a:prstGeom>
-          <a:solidFill>
-            <a:srgbClr val="F5A000"/>
-          </a:solidFill>
-          <a:ln>
-            <a:noFill/>
-          </a:ln>
-        </p:spPr>
-        <p:style>
-          <a:lnRef idx="1">
-            <a:schemeClr val="accent1"/>
-          </a:lnRef>
-          <a:fillRef idx="3">
-            <a:schemeClr val="accent1"/>
-          </a:fillRef>
-          <a:effectRef idx="2">
-            <a:schemeClr val="accent1"/>
-          </a:effectRef>
-          <a:fontRef idx="minor">
-            <a:schemeClr val="lt1"/>
-          </a:fontRef>
-        </p:style>
-        <p:txBody>
-          <a:bodyPr rtlCol="0" anchor="ctr"/>
-          <a:lstStyle/>
-          <a:p>
-            <a:pPr algn="ctr"/>
-          </a:p>
-        </p:txBody>
-      </p:sp>
-      <p:sp>
-        <p:nvSpPr>
-          <p:cNvPr id="31" name="TextBox 30"/>
-          <p:cNvSpPr txBox="1"/>
-          <p:nvPr/>
-        </p:nvSpPr>
-        <p:spPr>
-          <a:xfrm>
-            <a:off x="4343400" y="3831336"/>
-            <a:ext cx="3291840" cy="411480"/>
-          </a:xfrm>
-          <a:prstGeom prst="rect">
-            <a:avLst/>
-          </a:prstGeom>
-          <a:noFill/>
-        </p:spPr>
-        <p:txBody>
-          <a:bodyPr wrap="square">
-            <a:spAutoFit/>
-          </a:bodyPr>
-          <a:lstStyle/>
-          <a:p>
-            <a:pPr algn="l"/>
-            <a:r>
-              <a:rPr sz="1700" b="1" i="0">
-                <a:solidFill>
-                  <a:srgbClr val="1C3880"/>
-                </a:solidFill>
-                <a:latin typeface="Segoe UI"/>
-              </a:rPr>
-              <a:t>openpyxl</a:t>
-            </a:r>
-          </a:p>
-        </p:txBody>
-      </p:sp>
-      <p:sp>
-        <p:nvSpPr>
-          <p:cNvPr id="32" name="TextBox 31"/>
-          <p:cNvSpPr txBox="1"/>
-          <p:nvPr/>
-        </p:nvSpPr>
-        <p:spPr>
-          <a:xfrm>
-            <a:off x="4343400" y="4233672"/>
-            <a:ext cx="3291840" cy="274320"/>
-          </a:xfrm>
-          <a:prstGeom prst="rect">
-            <a:avLst/>
-          </a:prstGeom>
-          <a:noFill/>
-        </p:spPr>
-        <p:txBody>
-          <a:bodyPr wrap="square">
-            <a:spAutoFit/>
-          </a:bodyPr>
-          <a:lstStyle/>
-          <a:p>
-            <a:pPr algn="l"/>
-            <a:r>
-              <a:rPr sz="1100" b="1" i="1">
-                <a:solidFill>
-                  <a:srgbClr val="F5A000"/>
-                </a:solidFill>
-                <a:latin typeface="Segoe UI"/>
-              </a:rPr>
-              <a:t>Excel generation</a:t>
-            </a:r>
-          </a:p>
-        </p:txBody>
-      </p:sp>
-      <p:sp>
-        <p:nvSpPr>
-          <p:cNvPr id="33" name="TextBox 32"/>
-          <p:cNvSpPr txBox="1"/>
-          <p:nvPr/>
-        </p:nvSpPr>
-        <p:spPr>
-          <a:xfrm>
-            <a:off x="4343400" y="4526280"/>
-            <a:ext cx="3291840" cy="1005840"/>
-          </a:xfrm>
-          <a:prstGeom prst="rect">
-            <a:avLst/>
-          </a:prstGeom>
-          <a:noFill/>
-        </p:spPr>
-        <p:txBody>
-          <a:bodyPr wrap="square">
-            <a:spAutoFit/>
-          </a:bodyPr>
-          <a:lstStyle/>
+              <a:t>• Used internally at Amidel for live procurement tracking</a:t>
+            </a:r>
+          </a:p>
           <a:p>
             <a:pPr algn="l"/>
             <a:r>
@@ -17011,190 +16818,9 @@
                 </a:solidFill>
                 <a:latin typeface="Segoe UI"/>
               </a:rPr>
-              <a:t>Writes formatted .xlsx files with styled headers, borders, and hyperlinks.</a:t>
-            </a:r>
-          </a:p>
-        </p:txBody>
-      </p:sp>
-      <p:sp>
-        <p:nvSpPr>
-          <p:cNvPr id="34" name="Rectangle 33"/>
-          <p:cNvSpPr/>
-          <p:nvPr/>
-        </p:nvSpPr>
-        <p:spPr>
-          <a:xfrm>
-            <a:off x="7973568" y="3703320"/>
-            <a:ext cx="3520440" cy="2011680"/>
-          </a:xfrm>
-          <a:prstGeom prst="rect">
-            <a:avLst/>
-          </a:prstGeom>
-          <a:solidFill>
-            <a:srgbClr val="F4F6FA"/>
-          </a:solidFill>
-          <a:ln w="9525">
-            <a:solidFill>
-              <a:srgbClr val="E0E4EE"/>
-            </a:solidFill>
-          </a:ln>
-        </p:spPr>
-        <p:style>
-          <a:lnRef idx="1">
-            <a:schemeClr val="accent1"/>
-          </a:lnRef>
-          <a:fillRef idx="3">
-            <a:schemeClr val="accent1"/>
-          </a:fillRef>
-          <a:effectRef idx="2">
-            <a:schemeClr val="accent1"/>
-          </a:effectRef>
-          <a:fontRef idx="minor">
-            <a:schemeClr val="lt1"/>
-          </a:fontRef>
-        </p:style>
-        <p:txBody>
-          <a:bodyPr rtlCol="0" anchor="ctr"/>
-          <a:lstStyle/>
-          <a:p>
-            <a:pPr algn="ctr"/>
-          </a:p>
-        </p:txBody>
-      </p:sp>
-      <p:sp>
-        <p:nvSpPr>
-          <p:cNvPr id="35" name="Rectangle 34"/>
-          <p:cNvSpPr/>
-          <p:nvPr/>
-        </p:nvSpPr>
-        <p:spPr>
-          <a:xfrm>
-            <a:off x="7973568" y="3703320"/>
-            <a:ext cx="54864" cy="2011680"/>
-          </a:xfrm>
-          <a:prstGeom prst="rect">
-            <a:avLst/>
-          </a:prstGeom>
-          <a:solidFill>
-            <a:srgbClr val="F5A000"/>
-          </a:solidFill>
-          <a:ln>
-            <a:noFill/>
-          </a:ln>
-        </p:spPr>
-        <p:style>
-          <a:lnRef idx="1">
-            <a:schemeClr val="accent1"/>
-          </a:lnRef>
-          <a:fillRef idx="3">
-            <a:schemeClr val="accent1"/>
-          </a:fillRef>
-          <a:effectRef idx="2">
-            <a:schemeClr val="accent1"/>
-          </a:effectRef>
-          <a:fontRef idx="minor">
-            <a:schemeClr val="lt1"/>
-          </a:fontRef>
-        </p:style>
-        <p:txBody>
-          <a:bodyPr rtlCol="0" anchor="ctr"/>
-          <a:lstStyle/>
-          <a:p>
-            <a:pPr algn="ctr"/>
-          </a:p>
-        </p:txBody>
-      </p:sp>
-      <p:sp>
-        <p:nvSpPr>
-          <p:cNvPr id="36" name="TextBox 35"/>
-          <p:cNvSpPr txBox="1"/>
-          <p:nvPr/>
-        </p:nvSpPr>
-        <p:spPr>
-          <a:xfrm>
-            <a:off x="8138160" y="3831336"/>
-            <a:ext cx="3291840" cy="411480"/>
-          </a:xfrm>
-          <a:prstGeom prst="rect">
-            <a:avLst/>
-          </a:prstGeom>
-          <a:noFill/>
-        </p:spPr>
-        <p:txBody>
-          <a:bodyPr wrap="square">
-            <a:spAutoFit/>
-          </a:bodyPr>
-          <a:lstStyle/>
-          <a:p>
-            <a:pPr algn="l"/>
-            <a:r>
-              <a:rPr sz="1700" b="1" i="0">
-                <a:solidFill>
-                  <a:srgbClr val="1C3880"/>
-                </a:solidFill>
-                <a:latin typeface="Segoe UI"/>
-              </a:rPr>
-              <a:t>OneDrive</a:t>
-            </a:r>
-          </a:p>
-        </p:txBody>
-      </p:sp>
-      <p:sp>
-        <p:nvSpPr>
-          <p:cNvPr id="37" name="TextBox 36"/>
-          <p:cNvSpPr txBox="1"/>
-          <p:nvPr/>
-        </p:nvSpPr>
-        <p:spPr>
-          <a:xfrm>
-            <a:off x="8138160" y="4233672"/>
-            <a:ext cx="3291840" cy="274320"/>
-          </a:xfrm>
-          <a:prstGeom prst="rect">
-            <a:avLst/>
-          </a:prstGeom>
-          <a:noFill/>
-        </p:spPr>
-        <p:txBody>
-          <a:bodyPr wrap="square">
-            <a:spAutoFit/>
-          </a:bodyPr>
-          <a:lstStyle/>
-          <a:p>
-            <a:pPr algn="l"/>
-            <a:r>
-              <a:rPr sz="1100" b="1" i="1">
-                <a:solidFill>
-                  <a:srgbClr val="F5A000"/>
-                </a:solidFill>
-                <a:latin typeface="Segoe UI"/>
-              </a:rPr>
-              <a:t>File sync</a:t>
-            </a:r>
-          </a:p>
-        </p:txBody>
-      </p:sp>
-      <p:sp>
-        <p:nvSpPr>
-          <p:cNvPr id="38" name="TextBox 37"/>
-          <p:cNvSpPr txBox="1"/>
-          <p:nvPr/>
-        </p:nvSpPr>
-        <p:spPr>
-          <a:xfrm>
-            <a:off x="8138160" y="4526280"/>
-            <a:ext cx="3291840" cy="1005840"/>
-          </a:xfrm>
-          <a:prstGeom prst="rect">
-            <a:avLst/>
-          </a:prstGeom>
-          <a:noFill/>
-        </p:spPr>
-        <p:txBody>
-          <a:bodyPr wrap="square">
-            <a:spAutoFit/>
-          </a:bodyPr>
-          <a:lstStyle/>
+              <a:t>• Refined through real-world batch cycles</a:t>
+            </a:r>
+          </a:p>
           <a:p>
             <a:pPr algn="l"/>
             <a:r>
@@ -17204,7 +16830,19 @@
                 </a:solidFill>
                 <a:latin typeface="Segoe UI"/>
               </a:rPr>
-              <a:t>Equation file lives in OneDrive — updates are automatically available to all team members.</a:t>
+              <a:t>• Robust retry logic handles network and portal issues</a:t>
+            </a:r>
+          </a:p>
+          <a:p>
+            <a:pPr algn="l"/>
+            <a:r>
+              <a:rPr sz="1200" b="0" i="0">
+                <a:solidFill>
+                  <a:srgbClr val="333344"/>
+                </a:solidFill>
+                <a:latin typeface="Segoe UI"/>
+              </a:rPr>
+              <a:t>• Continuously improved based on team feedback</a:t>
             </a:r>
           </a:p>
         </p:txBody>

</xml_diff>